<commit_message>
Update PPT Problem Statement slides with verbatim original task text
Both make_pptx.py and make_clinical_pptx.py slide 2 previously showed
paraphrased/summarised problem descriptions. Updated to use the exact
wording from the original exam:

- Problem Statement: all 3 original bullets verbatim
- Instructions: all deliverables as given (embedding, LLM, evaluation,
  REST API, optional fine-tuning, max 10-page presentation,
  30-minute session)
- make_clinical_pptx.py also includes Target Audience and
  Additional Guidance verbatim

https://claude.ai/code/session_01HikGFqHKpu7poLxTbm8QFe
</commit_message>
<xml_diff>
--- a/Clinical_Note_Retrieval_Exam.pptx
+++ b/Clinical_Note_Retrieval_Exam.pptx
@@ -4158,7 +4158,7 @@
                   <a:srgbClr val="FFFFFF"/>
                 </a:solidFill>
               </a:rPr>
-              <a:t>Problem &amp; Motivation</a:t>
+              <a:t>Problem Statement</a:t>
             </a:r>
           </a:p>
         </p:txBody>
@@ -4193,7 +4193,7 @@
                   <a:srgbClr val="AACCDD"/>
                 </a:solidFill>
               </a:rPr>
-              <a:t>Why semantic retrieval matters in clinical settings</a:t>
+              <a:t>Problem 1 — Clinical Note Retrieval System</a:t>
             </a:r>
           </a:p>
         </p:txBody>
@@ -4271,7 +4271,7 @@
                   <a:srgbClr val="FFFFFF"/>
                 </a:solidFill>
               </a:rPr>
-              <a:t>The Clinical Challenge</a:t>
+              <a:t>Problem Statement</a:t>
             </a:r>
           </a:p>
         </p:txBody>
@@ -4285,7 +4285,7 @@
         <p:spPr>
           <a:xfrm>
             <a:off x="274320" y="1536192"/>
-            <a:ext cx="5577840" cy="4773168"/>
+            <a:ext cx="5577840" cy="2852928"/>
           </a:xfrm>
           <a:prstGeom prst="rect">
             <a:avLst/>
@@ -4328,7 +4328,7 @@
         <p:spPr>
           <a:xfrm>
             <a:off x="384048" y="1627632"/>
-            <a:ext cx="5358383" cy="4636007"/>
+            <a:ext cx="5358383" cy="2715768"/>
           </a:xfrm>
           <a:prstGeom prst="rect">
             <a:avLst/>
@@ -4353,7 +4353,7 @@
                   <a:srgbClr val="0A294A"/>
                 </a:solidFill>
               </a:rPr>
-              <a:t>Doctors spend ~30% of time searching past cases</a:t>
+              <a:t>The platform needs to help doctors quickly find</a:t>
             </a:r>
           </a:p>
           <a:p>
@@ -4368,6 +4368,36 @@
                   <a:srgbClr val="0A294A"/>
                 </a:solidFill>
               </a:rPr>
+              <a:t>relevant past cases from a large corpus of</a:t>
+            </a:r>
+          </a:p>
+          <a:p>
+            <a:pPr algn="l">
+              <a:spcBef>
+                <a:spcPts val="100"/>
+              </a:spcBef>
+            </a:pPr>
+            <a:r>
+              <a:rPr sz="1100" b="0" i="0">
+                <a:solidFill>
+                  <a:srgbClr val="0A294A"/>
+                </a:solidFill>
+              </a:rPr>
+              <a:t>clinical notes.</a:t>
+            </a:r>
+          </a:p>
+          <a:p>
+            <a:pPr algn="l">
+              <a:spcBef>
+                <a:spcPts val="100"/>
+              </a:spcBef>
+            </a:pPr>
+            <a:r>
+              <a:rPr sz="1100" b="0" i="0">
+                <a:solidFill>
+                  <a:srgbClr val="0A294A"/>
+                </a:solidFill>
+              </a:rPr>
               <a:t/>
             </a:r>
           </a:p>
@@ -4383,7 +4413,7 @@
                   <a:srgbClr val="0A294A"/>
                 </a:solidFill>
               </a:rPr>
-              <a:t>Keyword search fails with clinical synonym variation</a:t>
+              <a:t>A doctor types a natural language query describing</a:t>
             </a:r>
           </a:p>
           <a:p>
@@ -4398,7 +4428,7 @@
                   <a:srgbClr val="0A294A"/>
                 </a:solidFill>
               </a:rPr>
-              <a:t>  "CKD" ≠ "renal failure" to a search engine</a:t>
+              <a:t>a patient situation, and the system should surface</a:t>
             </a:r>
           </a:p>
           <a:p>
@@ -4413,6 +4443,21 @@
                   <a:srgbClr val="0A294A"/>
                 </a:solidFill>
               </a:rPr>
+              <a:t>the most relevant clinical notes from the database.</a:t>
+            </a:r>
+          </a:p>
+          <a:p>
+            <a:pPr algn="l">
+              <a:spcBef>
+                <a:spcPts val="100"/>
+              </a:spcBef>
+            </a:pPr>
+            <a:r>
+              <a:rPr sz="1100" b="0" i="0">
+                <a:solidFill>
+                  <a:srgbClr val="0A294A"/>
+                </a:solidFill>
+              </a:rPr>
               <a:t/>
             </a:r>
           </a:p>
@@ -4428,7 +4473,7 @@
                   <a:srgbClr val="0A294A"/>
                 </a:solidFill>
               </a:rPr>
-              <a:t>Large corpus (5 000+ notes) makes manual</a:t>
+              <a:t>The system must understand clinical meaning, not</a:t>
             </a:r>
           </a:p>
           <a:p>
@@ -4443,7 +4488,7 @@
                   <a:srgbClr val="0A294A"/>
                 </a:solidFill>
               </a:rPr>
-              <a:t>  review impossible within a consultation</a:t>
+              <a:t>just match keywords — a query about 'a diabetic</a:t>
             </a:r>
           </a:p>
           <a:p>
@@ -4458,7 +4503,7 @@
                   <a:srgbClr val="0A294A"/>
                 </a:solidFill>
               </a:rPr>
-              <a:t/>
+              <a:t>patient with kidney complications' should retrieve</a:t>
             </a:r>
           </a:p>
           <a:p>
@@ -4473,7 +4518,7 @@
                   <a:srgbClr val="0A294A"/>
                 </a:solidFill>
               </a:rPr>
-              <a:t>Critical information buried in unstructured text:</a:t>
+              <a:t>notes about CKD with diabetes even if the exact</a:t>
             </a:r>
           </a:p>
           <a:p>
@@ -4488,7 +4533,7 @@
                   <a:srgbClr val="0A294A"/>
                 </a:solidFill>
               </a:rPr>
-              <a:t>  transcriptions, discharge notes, consult letters</a:t>
+              <a:t>words differ.</a:t>
             </a:r>
           </a:p>
         </p:txBody>
@@ -4566,7 +4611,7 @@
                   <a:srgbClr val="FFFFFF"/>
                 </a:solidFill>
               </a:rPr>
-              <a:t>Our Goal</a:t>
+              <a:t>Instructions</a:t>
             </a:r>
           </a:p>
         </p:txBody>
@@ -4580,7 +4625,7 @@
         <p:spPr>
           <a:xfrm>
             <a:off x="6126480" y="1536192"/>
-            <a:ext cx="5760720" cy="4773168"/>
+            <a:ext cx="5760720" cy="2852928"/>
           </a:xfrm>
           <a:prstGeom prst="rect">
             <a:avLst/>
@@ -4623,7 +4668,7 @@
         <p:spPr>
           <a:xfrm>
             <a:off x="6236208" y="1627632"/>
-            <a:ext cx="5541264" cy="4636007"/>
+            <a:ext cx="5541264" cy="2715768"/>
           </a:xfrm>
           <a:prstGeom prst="rect">
             <a:avLst/>
@@ -4648,7 +4693,7 @@
                   <a:srgbClr val="0A294A"/>
                 </a:solidFill>
               </a:rPr>
-              <a:t>Semantic retrieval: meaning over keywords</a:t>
+              <a:t>Build a retrieval system:</a:t>
             </a:r>
           </a:p>
           <a:p>
@@ -4663,7 +4708,7 @@
                   <a:srgbClr val="0A294A"/>
                 </a:solidFill>
               </a:rPr>
-              <a:t/>
+              <a:t>  natural language query → ranked clinical notes</a:t>
             </a:r>
           </a:p>
           <a:p>
@@ -4678,7 +4723,7 @@
                   <a:srgbClr val="0A294A"/>
                 </a:solidFill>
               </a:rPr>
-              <a:t>Surface relevant notes even with different</a:t>
+              <a:t>Use an embedding model — justify your selection</a:t>
             </a:r>
           </a:p>
           <a:p>
@@ -4693,7 +4738,7 @@
                   <a:srgbClr val="0A294A"/>
                 </a:solidFill>
               </a:rPr>
-              <a:t>  vocabulary or abbreviation style</a:t>
+              <a:t>Add an LLM layer for a concise summary</a:t>
             </a:r>
           </a:p>
           <a:p>
@@ -4708,7 +4753,7 @@
                   <a:srgbClr val="0A294A"/>
                 </a:solidFill>
               </a:rPr>
-              <a:t/>
+              <a:t>Evaluate: clinically relevant, not keyword matches</a:t>
             </a:r>
           </a:p>
           <a:p>
@@ -4723,7 +4768,7 @@
                   <a:srgbClr val="0A294A"/>
                 </a:solidFill>
               </a:rPr>
-              <a:t>LLM summary so doctors get an answer,</a:t>
+              <a:t>(Optional) Fine-tune the embedding model</a:t>
             </a:r>
           </a:p>
           <a:p>
@@ -4738,7 +4783,7 @@
                   <a:srgbClr val="0A294A"/>
                 </a:solidFill>
               </a:rPr>
-              <a:t>  not just a ranked list of documents</a:t>
+              <a:t>Prepare a presentation — max 10 pages</a:t>
             </a:r>
           </a:p>
           <a:p>
@@ -4753,7 +4798,7 @@
                   <a:srgbClr val="0A294A"/>
                 </a:solidFill>
               </a:rPr>
-              <a:t/>
+              <a:t>Expose as a REST API service</a:t>
             </a:r>
           </a:p>
           <a:p>
@@ -4768,29 +4813,122 @@
                   <a:srgbClr val="0A294A"/>
                 </a:solidFill>
               </a:rPr>
-              <a:t>REST API exposing the system as a service</a:t>
-            </a:r>
-          </a:p>
-          <a:p>
-            <a:pPr algn="l">
-              <a:spcBef>
-                <a:spcPts val="100"/>
-              </a:spcBef>
-            </a:pPr>
-            <a:r>
-              <a:rPr sz="1100" b="0" i="0">
-                <a:solidFill>
-                  <a:srgbClr val="0A294A"/>
-                </a:solidFill>
-              </a:rPr>
-              <a:t>  so any EHR or front-end can consume it</a:t>
-            </a:r>
-          </a:p>
-        </p:txBody>
-      </p:sp>
-      <p:sp>
-        <p:nvSpPr>
-          <p:cNvPr id="14" name="TextBox 13"/>
+              <a:t>Prepare to present — 30-minute session</a:t>
+            </a:r>
+          </a:p>
+        </p:txBody>
+      </p:sp>
+      <p:sp>
+        <p:nvSpPr>
+          <p:cNvPr id="14" name="Rectangle 13"/>
+          <p:cNvSpPr/>
+          <p:nvPr/>
+        </p:nvSpPr>
+        <p:spPr>
+          <a:xfrm>
+            <a:off x="274320" y="4617720"/>
+            <a:ext cx="11612880" cy="1691640"/>
+          </a:xfrm>
+          <a:prstGeom prst="rect">
+            <a:avLst/>
+          </a:prstGeom>
+          <a:solidFill>
+            <a:srgbClr val="0A294A"/>
+          </a:solidFill>
+          <a:ln>
+            <a:noFill/>
+          </a:ln>
+        </p:spPr>
+        <p:style>
+          <a:lnRef idx="1">
+            <a:schemeClr val="accent1"/>
+          </a:lnRef>
+          <a:fillRef idx="3">
+            <a:schemeClr val="accent1"/>
+          </a:fillRef>
+          <a:effectRef idx="2">
+            <a:schemeClr val="accent1"/>
+          </a:effectRef>
+          <a:fontRef idx="minor">
+            <a:schemeClr val="lt1"/>
+          </a:fontRef>
+        </p:style>
+        <p:txBody>
+          <a:bodyPr rtlCol="0" anchor="ctr"/>
+          <a:lstStyle/>
+          <a:p>
+            <a:pPr algn="ctr"/>
+          </a:p>
+        </p:txBody>
+      </p:sp>
+      <p:sp>
+        <p:nvSpPr>
+          <p:cNvPr id="15" name="TextBox 14"/>
+          <p:cNvSpPr txBox="1"/>
+          <p:nvPr/>
+        </p:nvSpPr>
+        <p:spPr>
+          <a:xfrm>
+            <a:off x="457200" y="4690872"/>
+            <a:ext cx="11247120" cy="1508760"/>
+          </a:xfrm>
+          <a:prstGeom prst="rect">
+            <a:avLst/>
+          </a:prstGeom>
+          <a:noFill/>
+        </p:spPr>
+        <p:txBody>
+          <a:bodyPr wrap="square">
+            <a:spAutoFit/>
+          </a:bodyPr>
+          <a:lstStyle/>
+          <a:p/>
+          <a:p>
+            <a:pPr algn="l"/>
+            <a:r>
+              <a:rPr sz="1300" b="1" i="0">
+                <a:solidFill>
+                  <a:srgbClr val="007A87"/>
+                </a:solidFill>
+              </a:rPr>
+              <a:t>Target Audience  ·  Additional Guidance</a:t>
+            </a:r>
+          </a:p>
+          <a:p>
+            <a:pPr algn="l">
+              <a:spcBef>
+                <a:spcPts val="400"/>
+              </a:spcBef>
+            </a:pPr>
+            <a:r>
+              <a:rPr sz="1200" b="0" i="0">
+                <a:solidFill>
+                  <a:srgbClr val="CCDDFF"/>
+                </a:solidFill>
+              </a:rPr>
+              <a:t>AI Engineering Manager  ·  Product Manager</a:t>
+            </a:r>
+          </a:p>
+          <a:p>
+            <a:pPr algn="l">
+              <a:spcBef>
+                <a:spcPts val="400"/>
+              </a:spcBef>
+            </a:pPr>
+            <a:r>
+              <a:rPr sz="1200" b="0" i="0">
+                <a:solidFill>
+                  <a:srgbClr val="FFFFFF"/>
+                </a:solidFill>
+              </a:rPr>
+              <a:t>Anything outside this instruction, please feel free to make your own assumption as needed.</a:t>
+            </a:r>
+          </a:p>
+        </p:txBody>
+      </p:sp>
+      <p:sp>
+        <p:nvSpPr>
+          <p:cNvPr id="16" name="TextBox 15"/>
           <p:cNvSpPr txBox="1"/>
           <p:nvPr/>
         </p:nvSpPr>

</xml_diff>

<commit_message>
Fix layout overlaps, dark_section heights, and add HTML exam document
- Fix cfp/p() empty-paragraph bug: reuse first paragraph instead of
  adding new one, preventing invisible blank line pushing text out of bounds
- Fix dark_section content box overflow on slides 13, 15, 22, 23, 24, 28:
  shorten text to fit available height; increase s28 height to 1.10" and
  adjust assumption card positions to avoid overlap
- Fix dark2 text overflow on s22 and s25: tighten sentences to fit 0.56"
  and 0.64" content boxes respectively
- Fix slide 10 exam footer overlap (moved to y=6.68")
- Add CLINICAL_EXAM.html: self-contained styled HTML version of the writeup
- Both PPTXes audit clean (no shapes below y=6.95")

https://claude.ai/code/session_01HikGFqHKpu7poLxTbm8QFe
</commit_message>
<xml_diff>
--- a/Clinical_Note_Retrieval_Exam.pptx
+++ b/Clinical_Note_Retrieval_Exam.pptx
@@ -3204,7 +3204,6 @@
             <a:spAutoFit/>
           </a:bodyPr>
           <a:lstStyle/>
-          <a:p/>
           <a:p>
             <a:pPr algn="l"/>
             <a:r>
@@ -3239,7 +3238,6 @@
             <a:spAutoFit/>
           </a:bodyPr>
           <a:lstStyle/>
-          <a:p/>
           <a:p>
             <a:pPr algn="l"/>
             <a:r>
@@ -3274,7 +3272,6 @@
             <a:spAutoFit/>
           </a:bodyPr>
           <a:lstStyle/>
-          <a:p/>
           <a:p>
             <a:pPr algn="l"/>
             <a:r>
@@ -3395,7 +3392,6 @@
             <a:spAutoFit/>
           </a:bodyPr>
           <a:lstStyle/>
-          <a:p/>
           <a:p>
             <a:pPr algn="l"/>
             <a:r>
@@ -3430,7 +3426,6 @@
             <a:spAutoFit/>
           </a:bodyPr>
           <a:lstStyle/>
-          <a:p/>
           <a:p>
             <a:pPr algn="l"/>
             <a:r>
@@ -3508,7 +3503,6 @@
             <a:spAutoFit/>
           </a:bodyPr>
           <a:lstStyle/>
-          <a:p/>
           <a:p>
             <a:pPr algn="l"/>
             <a:r>
@@ -3543,7 +3537,6 @@
             <a:spAutoFit/>
           </a:bodyPr>
           <a:lstStyle/>
-          <a:p/>
           <a:p>
             <a:pPr algn="l"/>
             <a:r>
@@ -3621,7 +3614,6 @@
             <a:spAutoFit/>
           </a:bodyPr>
           <a:lstStyle/>
-          <a:p/>
           <a:p>
             <a:pPr algn="l"/>
             <a:r>
@@ -3656,7 +3648,6 @@
             <a:spAutoFit/>
           </a:bodyPr>
           <a:lstStyle/>
-          <a:p/>
           <a:p>
             <a:pPr algn="l"/>
             <a:r>
@@ -3734,7 +3725,6 @@
             <a:spAutoFit/>
           </a:bodyPr>
           <a:lstStyle/>
-          <a:p/>
           <a:p>
             <a:pPr algn="l"/>
             <a:r>
@@ -3769,7 +3759,6 @@
             <a:spAutoFit/>
           </a:bodyPr>
           <a:lstStyle/>
-          <a:p/>
           <a:p>
             <a:pPr algn="l"/>
             <a:r>
@@ -3804,7 +3793,6 @@
             <a:spAutoFit/>
           </a:bodyPr>
           <a:lstStyle/>
-          <a:p/>
           <a:p>
             <a:pPr algn="l"/>
             <a:r>
@@ -3839,7 +3827,6 @@
             <a:spAutoFit/>
           </a:bodyPr>
           <a:lstStyle/>
-          <a:p/>
           <a:p>
             <a:pPr algn="l"/>
             <a:r>
@@ -3874,7 +3861,6 @@
             <a:spAutoFit/>
           </a:bodyPr>
           <a:lstStyle/>
-          <a:p/>
           <a:p>
             <a:pPr algn="l"/>
             <a:r>
@@ -3909,7 +3895,6 @@
             <a:spAutoFit/>
           </a:bodyPr>
           <a:lstStyle/>
-          <a:p/>
           <a:p>
             <a:pPr algn="l"/>
             <a:r>
@@ -3944,7 +3929,6 @@
             <a:spAutoFit/>
           </a:bodyPr>
           <a:lstStyle/>
-          <a:p/>
           <a:p>
             <a:pPr algn="l"/>
             <a:r>
@@ -3979,7 +3963,6 @@
             <a:spAutoFit/>
           </a:bodyPr>
           <a:lstStyle/>
-          <a:p/>
           <a:p>
             <a:pPr algn="l"/>
             <a:r>
@@ -4014,7 +3997,6 @@
             <a:spAutoFit/>
           </a:bodyPr>
           <a:lstStyle/>
-          <a:p/>
           <a:p>
             <a:pPr algn="l"/>
             <a:r>
@@ -4049,7 +4031,6 @@
             <a:spAutoFit/>
           </a:bodyPr>
           <a:lstStyle/>
-          <a:p/>
           <a:p>
             <a:pPr algn="l"/>
             <a:r>
@@ -4084,7 +4065,6 @@
             <a:spAutoFit/>
           </a:bodyPr>
           <a:lstStyle/>
-          <a:p/>
           <a:p>
             <a:pPr algn="l"/>
             <a:r>
@@ -4119,7 +4099,6 @@
             <a:spAutoFit/>
           </a:bodyPr>
           <a:lstStyle/>
-          <a:p/>
           <a:p>
             <a:pPr algn="l"/>
             <a:r>
@@ -4154,7 +4133,6 @@
             <a:spAutoFit/>
           </a:bodyPr>
           <a:lstStyle/>
-          <a:p/>
           <a:p>
             <a:pPr algn="r"/>
             <a:r>
@@ -4293,7 +4271,6 @@
             <a:spAutoFit/>
           </a:bodyPr>
           <a:lstStyle/>
-          <a:p/>
           <a:p>
             <a:pPr algn="l"/>
             <a:r>
@@ -4371,7 +4348,6 @@
             <a:spAutoFit/>
           </a:bodyPr>
           <a:lstStyle/>
-          <a:p/>
           <a:p>
             <a:pPr algn="l"/>
             <a:r>
@@ -4406,7 +4382,6 @@
             <a:spAutoFit/>
           </a:bodyPr>
           <a:lstStyle/>
-          <a:p/>
           <a:p>
             <a:pPr algn="l">
               <a:spcBef>
@@ -4668,7 +4643,6 @@
             <a:spAutoFit/>
           </a:bodyPr>
           <a:lstStyle/>
-          <a:p/>
           <a:p>
             <a:pPr algn="l"/>
             <a:r>
@@ -4703,7 +4677,6 @@
             <a:spAutoFit/>
           </a:bodyPr>
           <a:lstStyle/>
-          <a:p/>
           <a:p>
             <a:pPr algn="l">
               <a:spcBef>
@@ -4924,20 +4897,19 @@
         </p:nvSpPr>
         <p:spPr>
           <a:xfrm>
-            <a:off x="411480" y="6190488"/>
-            <a:ext cx="11430000" cy="201168"/>
-          </a:xfrm>
-          <a:prstGeom prst="rect">
-            <a:avLst/>
-          </a:prstGeom>
-          <a:noFill/>
-        </p:spPr>
-        <p:txBody>
-          <a:bodyPr wrap="square">
-            <a:spAutoFit/>
-          </a:bodyPr>
-          <a:lstStyle/>
-          <a:p/>
+            <a:off x="411480" y="6108192"/>
+            <a:ext cx="11430000" cy="182880"/>
+          </a:xfrm>
+          <a:prstGeom prst="rect">
+            <a:avLst/>
+          </a:prstGeom>
+          <a:noFill/>
+        </p:spPr>
+        <p:txBody>
+          <a:bodyPr wrap="square">
+            <a:spAutoFit/>
+          </a:bodyPr>
+          <a:lstStyle/>
           <a:p>
             <a:pPr algn="ctr"/>
             <a:r>
@@ -4972,7 +4944,6 @@
             <a:spAutoFit/>
           </a:bodyPr>
           <a:lstStyle/>
-          <a:p/>
           <a:p>
             <a:pPr algn="r"/>
             <a:r>
@@ -5111,7 +5082,6 @@
             <a:spAutoFit/>
           </a:bodyPr>
           <a:lstStyle/>
-          <a:p/>
           <a:p>
             <a:pPr algn="l"/>
             <a:r>
@@ -5146,7 +5116,6 @@
             <a:spAutoFit/>
           </a:bodyPr>
           <a:lstStyle/>
-          <a:p/>
           <a:p>
             <a:pPr algn="l"/>
             <a:r>
@@ -5224,7 +5193,6 @@
             <a:spAutoFit/>
           </a:bodyPr>
           <a:lstStyle/>
-          <a:p/>
           <a:p>
             <a:pPr algn="l"/>
             <a:r>
@@ -5302,7 +5270,6 @@
             <a:spAutoFit/>
           </a:bodyPr>
           <a:lstStyle/>
-          <a:p/>
           <a:p>
             <a:pPr algn="l">
               <a:spcBef>
@@ -5534,7 +5501,6 @@
             <a:spAutoFit/>
           </a:bodyPr>
           <a:lstStyle/>
-          <a:p/>
           <a:p>
             <a:pPr algn="l"/>
             <a:r>
@@ -5612,7 +5578,6 @@
             <a:spAutoFit/>
           </a:bodyPr>
           <a:lstStyle/>
-          <a:p/>
           <a:p>
             <a:pPr algn="l">
               <a:spcBef>
@@ -5829,7 +5794,6 @@
             <a:spAutoFit/>
           </a:bodyPr>
           <a:lstStyle/>
-          <a:p/>
           <a:p>
             <a:pPr algn="l"/>
             <a:r>
@@ -5864,7 +5828,6 @@
             <a:spAutoFit/>
           </a:bodyPr>
           <a:lstStyle/>
-          <a:p/>
           <a:p>
             <a:pPr algn="l"/>
             <a:r>
@@ -5899,7 +5862,6 @@
             <a:spAutoFit/>
           </a:bodyPr>
           <a:lstStyle/>
-          <a:p/>
           <a:p>
             <a:pPr algn="l"/>
             <a:r>
@@ -5934,7 +5896,6 @@
             <a:spAutoFit/>
           </a:bodyPr>
           <a:lstStyle/>
-          <a:p/>
           <a:p>
             <a:pPr algn="l"/>
             <a:r>
@@ -5969,7 +5930,6 @@
             <a:spAutoFit/>
           </a:bodyPr>
           <a:lstStyle/>
-          <a:p/>
           <a:p>
             <a:pPr algn="r"/>
             <a:r>
@@ -6108,7 +6068,6 @@
             <a:spAutoFit/>
           </a:bodyPr>
           <a:lstStyle/>
-          <a:p/>
           <a:p>
             <a:pPr algn="l"/>
             <a:r>
@@ -6143,7 +6102,6 @@
             <a:spAutoFit/>
           </a:bodyPr>
           <a:lstStyle/>
-          <a:p/>
           <a:p>
             <a:pPr algn="l"/>
             <a:r>
@@ -6221,7 +6179,6 @@
             <a:spAutoFit/>
           </a:bodyPr>
           <a:lstStyle/>
-          <a:p/>
           <a:p>
             <a:pPr algn="l"/>
             <a:r>
@@ -6299,7 +6256,6 @@
             <a:spAutoFit/>
           </a:bodyPr>
           <a:lstStyle/>
-          <a:p/>
           <a:p>
             <a:pPr algn="l">
               <a:spcBef>
@@ -6441,7 +6397,6 @@
             <a:spAutoFit/>
           </a:bodyPr>
           <a:lstStyle/>
-          <a:p/>
           <a:p>
             <a:pPr algn="l"/>
             <a:r>
@@ -6519,7 +6474,6 @@
             <a:spAutoFit/>
           </a:bodyPr>
           <a:lstStyle/>
-          <a:p/>
           <a:p>
             <a:pPr algn="l">
               <a:spcBef>
@@ -6661,7 +6615,6 @@
             <a:spAutoFit/>
           </a:bodyPr>
           <a:lstStyle/>
-          <a:p/>
           <a:p>
             <a:pPr algn="l"/>
             <a:r>
@@ -6739,7 +6692,6 @@
             <a:spAutoFit/>
           </a:bodyPr>
           <a:lstStyle/>
-          <a:p/>
           <a:p>
             <a:pPr algn="l">
               <a:spcBef>
@@ -6881,7 +6833,6 @@
             <a:spAutoFit/>
           </a:bodyPr>
           <a:lstStyle/>
-          <a:p/>
           <a:p>
             <a:pPr algn="l"/>
             <a:r>
@@ -6959,7 +6910,6 @@
             <a:spAutoFit/>
           </a:bodyPr>
           <a:lstStyle/>
-          <a:p/>
           <a:p>
             <a:pPr algn="l">
               <a:spcBef>
@@ -7101,7 +7051,6 @@
             <a:spAutoFit/>
           </a:bodyPr>
           <a:lstStyle/>
-          <a:p/>
           <a:p>
             <a:pPr algn="l"/>
             <a:r>
@@ -7136,7 +7085,6 @@
             <a:spAutoFit/>
           </a:bodyPr>
           <a:lstStyle/>
-          <a:p/>
           <a:p>
             <a:pPr algn="l"/>
             <a:r>
@@ -7214,7 +7162,6 @@
             <a:spAutoFit/>
           </a:bodyPr>
           <a:lstStyle/>
-          <a:p/>
           <a:p>
             <a:pPr algn="l"/>
             <a:r>
@@ -7292,7 +7239,6 @@
             <a:spAutoFit/>
           </a:bodyPr>
           <a:lstStyle/>
-          <a:p/>
           <a:p>
             <a:pPr algn="l"/>
             <a:r>
@@ -7327,7 +7273,6 @@
             <a:spAutoFit/>
           </a:bodyPr>
           <a:lstStyle/>
-          <a:p/>
           <a:p>
             <a:pPr algn="l"/>
             <a:r>
@@ -7362,7 +7307,6 @@
             <a:spAutoFit/>
           </a:bodyPr>
           <a:lstStyle/>
-          <a:p/>
           <a:p>
             <a:pPr algn="l"/>
             <a:r>
@@ -7440,7 +7384,6 @@
             <a:spAutoFit/>
           </a:bodyPr>
           <a:lstStyle/>
-          <a:p/>
           <a:p>
             <a:pPr algn="l"/>
             <a:r>
@@ -7475,7 +7418,6 @@
             <a:spAutoFit/>
           </a:bodyPr>
           <a:lstStyle/>
-          <a:p/>
           <a:p>
             <a:pPr algn="l"/>
             <a:r>
@@ -7510,7 +7452,6 @@
             <a:spAutoFit/>
           </a:bodyPr>
           <a:lstStyle/>
-          <a:p/>
           <a:p>
             <a:pPr algn="l"/>
             <a:r>
@@ -7588,7 +7529,6 @@
             <a:spAutoFit/>
           </a:bodyPr>
           <a:lstStyle/>
-          <a:p/>
           <a:p>
             <a:pPr algn="l"/>
             <a:r>
@@ -7623,7 +7563,6 @@
             <a:spAutoFit/>
           </a:bodyPr>
           <a:lstStyle/>
-          <a:p/>
           <a:p>
             <a:pPr algn="l"/>
             <a:r>
@@ -7658,7 +7597,6 @@
             <a:spAutoFit/>
           </a:bodyPr>
           <a:lstStyle/>
-          <a:p/>
           <a:p>
             <a:pPr algn="l"/>
             <a:r>
@@ -7736,7 +7674,6 @@
             <a:spAutoFit/>
           </a:bodyPr>
           <a:lstStyle/>
-          <a:p/>
           <a:p>
             <a:pPr algn="l"/>
             <a:r>
@@ -7771,7 +7708,6 @@
             <a:spAutoFit/>
           </a:bodyPr>
           <a:lstStyle/>
-          <a:p/>
           <a:p>
             <a:pPr algn="l"/>
             <a:r>
@@ -7806,7 +7742,6 @@
             <a:spAutoFit/>
           </a:bodyPr>
           <a:lstStyle/>
-          <a:p/>
           <a:p>
             <a:pPr algn="l"/>
             <a:r>
@@ -7884,7 +7819,6 @@
             <a:spAutoFit/>
           </a:bodyPr>
           <a:lstStyle/>
-          <a:p/>
           <a:p>
             <a:pPr algn="l"/>
             <a:r>
@@ -7919,7 +7853,6 @@
             <a:spAutoFit/>
           </a:bodyPr>
           <a:lstStyle/>
-          <a:p/>
           <a:p>
             <a:pPr algn="l"/>
             <a:r>
@@ -7954,7 +7887,6 @@
             <a:spAutoFit/>
           </a:bodyPr>
           <a:lstStyle/>
-          <a:p/>
           <a:p>
             <a:pPr algn="l"/>
             <a:r>
@@ -7989,7 +7921,6 @@
             <a:spAutoFit/>
           </a:bodyPr>
           <a:lstStyle/>
-          <a:p/>
           <a:p>
             <a:pPr algn="l"/>
             <a:r>
@@ -8024,7 +7955,6 @@
             <a:spAutoFit/>
           </a:bodyPr>
           <a:lstStyle/>
-          <a:p/>
           <a:p>
             <a:pPr algn="r"/>
             <a:r>
@@ -8163,7 +8093,6 @@
             <a:spAutoFit/>
           </a:bodyPr>
           <a:lstStyle/>
-          <a:p/>
           <a:p>
             <a:pPr algn="l"/>
             <a:r>
@@ -8198,7 +8127,6 @@
             <a:spAutoFit/>
           </a:bodyPr>
           <a:lstStyle/>
-          <a:p/>
           <a:p>
             <a:pPr algn="l"/>
             <a:r>
@@ -8276,7 +8204,6 @@
             <a:spAutoFit/>
           </a:bodyPr>
           <a:lstStyle/>
-          <a:p/>
           <a:p>
             <a:pPr algn="l"/>
             <a:r>
@@ -8354,7 +8281,6 @@
             <a:spAutoFit/>
           </a:bodyPr>
           <a:lstStyle/>
-          <a:p/>
           <a:p>
             <a:pPr algn="l">
               <a:spcBef>
@@ -8438,7 +8364,6 @@
             <a:spAutoFit/>
           </a:bodyPr>
           <a:lstStyle/>
-          <a:p/>
           <a:p>
             <a:pPr algn="l"/>
             <a:r>
@@ -8516,7 +8441,6 @@
             <a:spAutoFit/>
           </a:bodyPr>
           <a:lstStyle/>
-          <a:p/>
           <a:p>
             <a:pPr algn="l"/>
             <a:r>
@@ -8594,7 +8518,6 @@
             <a:spAutoFit/>
           </a:bodyPr>
           <a:lstStyle/>
-          <a:p/>
           <a:p>
             <a:pPr algn="l">
               <a:spcBef>
@@ -8678,7 +8601,6 @@
             <a:spAutoFit/>
           </a:bodyPr>
           <a:lstStyle/>
-          <a:p/>
           <a:p>
             <a:pPr algn="l"/>
             <a:r>
@@ -8756,7 +8678,6 @@
             <a:spAutoFit/>
           </a:bodyPr>
           <a:lstStyle/>
-          <a:p/>
           <a:p>
             <a:pPr algn="l"/>
             <a:r>
@@ -8834,7 +8755,6 @@
             <a:spAutoFit/>
           </a:bodyPr>
           <a:lstStyle/>
-          <a:p/>
           <a:p>
             <a:pPr algn="l">
               <a:spcBef>
@@ -8918,7 +8838,6 @@
             <a:spAutoFit/>
           </a:bodyPr>
           <a:lstStyle/>
-          <a:p/>
           <a:p>
             <a:pPr algn="l"/>
             <a:r>
@@ -8996,7 +8915,6 @@
             <a:spAutoFit/>
           </a:bodyPr>
           <a:lstStyle/>
-          <a:p/>
           <a:p>
             <a:pPr algn="l"/>
             <a:r>
@@ -9074,7 +8992,6 @@
             <a:spAutoFit/>
           </a:bodyPr>
           <a:lstStyle/>
-          <a:p/>
           <a:p>
             <a:pPr algn="l">
               <a:spcBef>
@@ -9158,7 +9075,6 @@
             <a:spAutoFit/>
           </a:bodyPr>
           <a:lstStyle/>
-          <a:p/>
           <a:p>
             <a:pPr algn="l"/>
             <a:r>
@@ -9236,7 +9152,6 @@
             <a:spAutoFit/>
           </a:bodyPr>
           <a:lstStyle/>
-          <a:p/>
           <a:p>
             <a:pPr algn="l"/>
             <a:r>
@@ -9314,7 +9229,6 @@
             <a:spAutoFit/>
           </a:bodyPr>
           <a:lstStyle/>
-          <a:p/>
           <a:p>
             <a:pPr algn="l">
               <a:spcBef>
@@ -9441,7 +9355,6 @@
             <a:spAutoFit/>
           </a:bodyPr>
           <a:lstStyle/>
-          <a:p/>
           <a:p>
             <a:pPr algn="l"/>
             <a:r>
@@ -9476,7 +9389,6 @@
             <a:spAutoFit/>
           </a:bodyPr>
           <a:lstStyle/>
-          <a:p/>
           <a:p>
             <a:pPr algn="l">
               <a:spcBef>
@@ -9648,7 +9560,6 @@
             <a:spAutoFit/>
           </a:bodyPr>
           <a:lstStyle/>
-          <a:p/>
           <a:p>
             <a:pPr algn="l"/>
             <a:r>
@@ -9683,7 +9594,6 @@
             <a:spAutoFit/>
           </a:bodyPr>
           <a:lstStyle/>
-          <a:p/>
           <a:p>
             <a:pPr algn="l">
               <a:spcBef>
@@ -9812,7 +9722,6 @@
             <a:spAutoFit/>
           </a:bodyPr>
           <a:lstStyle/>
-          <a:p/>
           <a:p>
             <a:pPr algn="r"/>
             <a:r>
@@ -9951,7 +9860,6 @@
             <a:spAutoFit/>
           </a:bodyPr>
           <a:lstStyle/>
-          <a:p/>
           <a:p>
             <a:pPr algn="l"/>
             <a:r>
@@ -9986,7 +9894,6 @@
             <a:spAutoFit/>
           </a:bodyPr>
           <a:lstStyle/>
-          <a:p/>
           <a:p>
             <a:pPr algn="l"/>
             <a:r>
@@ -10064,7 +9971,6 @@
             <a:spAutoFit/>
           </a:bodyPr>
           <a:lstStyle/>
-          <a:p/>
           <a:p>
             <a:pPr algn="l"/>
             <a:r>
@@ -10185,7 +10091,6 @@
             <a:spAutoFit/>
           </a:bodyPr>
           <a:lstStyle/>
-          <a:p/>
           <a:p>
             <a:pPr algn="l"/>
             <a:r>
@@ -10220,7 +10125,6 @@
             <a:spAutoFit/>
           </a:bodyPr>
           <a:lstStyle/>
-          <a:p/>
           <a:p>
             <a:pPr algn="ctr"/>
             <a:r>
@@ -10255,7 +10159,6 @@
             <a:spAutoFit/>
           </a:bodyPr>
           <a:lstStyle/>
-          <a:p/>
           <a:p>
             <a:pPr algn="l"/>
             <a:r>
@@ -10290,7 +10193,6 @@
             <a:spAutoFit/>
           </a:bodyPr>
           <a:lstStyle/>
-          <a:p/>
           <a:p>
             <a:pPr algn="l"/>
             <a:r>
@@ -10325,7 +10227,6 @@
             <a:spAutoFit/>
           </a:bodyPr>
           <a:lstStyle/>
-          <a:p/>
           <a:p>
             <a:pPr algn="l"/>
             <a:r>
@@ -10446,7 +10347,6 @@
             <a:spAutoFit/>
           </a:bodyPr>
           <a:lstStyle/>
-          <a:p/>
           <a:p>
             <a:pPr algn="l"/>
             <a:r>
@@ -10481,7 +10381,6 @@
             <a:spAutoFit/>
           </a:bodyPr>
           <a:lstStyle/>
-          <a:p/>
           <a:p>
             <a:pPr algn="ctr"/>
             <a:r>
@@ -10516,7 +10415,6 @@
             <a:spAutoFit/>
           </a:bodyPr>
           <a:lstStyle/>
-          <a:p/>
           <a:p>
             <a:pPr algn="l"/>
             <a:r>
@@ -10551,7 +10449,6 @@
             <a:spAutoFit/>
           </a:bodyPr>
           <a:lstStyle/>
-          <a:p/>
           <a:p>
             <a:pPr algn="l"/>
             <a:r>
@@ -10586,7 +10483,6 @@
             <a:spAutoFit/>
           </a:bodyPr>
           <a:lstStyle/>
-          <a:p/>
           <a:p>
             <a:pPr algn="l"/>
             <a:r>
@@ -10707,7 +10603,6 @@
             <a:spAutoFit/>
           </a:bodyPr>
           <a:lstStyle/>
-          <a:p/>
           <a:p>
             <a:pPr algn="l"/>
             <a:r>
@@ -10742,7 +10637,6 @@
             <a:spAutoFit/>
           </a:bodyPr>
           <a:lstStyle/>
-          <a:p/>
           <a:p>
             <a:pPr algn="ctr"/>
             <a:r>
@@ -10777,7 +10671,6 @@
             <a:spAutoFit/>
           </a:bodyPr>
           <a:lstStyle/>
-          <a:p/>
           <a:p>
             <a:pPr algn="l"/>
             <a:r>
@@ -10812,7 +10705,6 @@
             <a:spAutoFit/>
           </a:bodyPr>
           <a:lstStyle/>
-          <a:p/>
           <a:p>
             <a:pPr algn="l"/>
             <a:r>
@@ -10847,7 +10739,6 @@
             <a:spAutoFit/>
           </a:bodyPr>
           <a:lstStyle/>
-          <a:p/>
           <a:p>
             <a:pPr algn="l"/>
             <a:r>
@@ -10925,7 +10816,6 @@
             <a:spAutoFit/>
           </a:bodyPr>
           <a:lstStyle/>
-          <a:p/>
           <a:p>
             <a:pPr algn="l"/>
             <a:r>
@@ -10960,7 +10850,6 @@
             <a:spAutoFit/>
           </a:bodyPr>
           <a:lstStyle/>
-          <a:p/>
           <a:p>
             <a:pPr algn="l">
               <a:spcBef>
@@ -11102,7 +10991,6 @@
             <a:spAutoFit/>
           </a:bodyPr>
           <a:lstStyle/>
-          <a:p/>
           <a:p>
             <a:pPr algn="l"/>
             <a:r>
@@ -11137,7 +11025,6 @@
             <a:spAutoFit/>
           </a:bodyPr>
           <a:lstStyle/>
-          <a:p/>
           <a:p>
             <a:pPr algn="l">
               <a:spcBef>
@@ -11279,7 +11166,6 @@
             <a:spAutoFit/>
           </a:bodyPr>
           <a:lstStyle/>
-          <a:p/>
           <a:p>
             <a:pPr algn="l"/>
             <a:r>
@@ -11357,7 +11243,6 @@
             <a:spAutoFit/>
           </a:bodyPr>
           <a:lstStyle/>
-          <a:p/>
           <a:p>
             <a:pPr algn="l">
               <a:spcBef>
@@ -11514,7 +11399,6 @@
             <a:spAutoFit/>
           </a:bodyPr>
           <a:lstStyle/>
-          <a:p/>
           <a:p>
             <a:pPr algn="l"/>
             <a:r>
@@ -11592,7 +11476,6 @@
             <a:spAutoFit/>
           </a:bodyPr>
           <a:lstStyle/>
-          <a:p/>
           <a:p>
             <a:pPr algn="l">
               <a:spcBef>
@@ -11749,7 +11632,6 @@
             <a:spAutoFit/>
           </a:bodyPr>
           <a:lstStyle/>
-          <a:p/>
           <a:p>
             <a:pPr algn="l"/>
             <a:r>
@@ -11827,7 +11709,6 @@
             <a:spAutoFit/>
           </a:bodyPr>
           <a:lstStyle/>
-          <a:p/>
           <a:p>
             <a:pPr algn="l">
               <a:spcBef>
@@ -11941,7 +11822,6 @@
             <a:spAutoFit/>
           </a:bodyPr>
           <a:lstStyle/>
-          <a:p/>
           <a:p>
             <a:pPr algn="r"/>
             <a:r>
@@ -12080,7 +11960,6 @@
             <a:spAutoFit/>
           </a:bodyPr>
           <a:lstStyle/>
-          <a:p/>
           <a:p>
             <a:pPr algn="l"/>
             <a:r>
@@ -12115,7 +11994,6 @@
             <a:spAutoFit/>
           </a:bodyPr>
           <a:lstStyle/>
-          <a:p/>
           <a:p>
             <a:pPr algn="l"/>
             <a:r>
@@ -12193,7 +12071,6 @@
             <a:spAutoFit/>
           </a:bodyPr>
           <a:lstStyle/>
-          <a:p/>
           <a:p>
             <a:pPr algn="l"/>
             <a:r>
@@ -12228,7 +12105,6 @@
             <a:spAutoFit/>
           </a:bodyPr>
           <a:lstStyle/>
-          <a:p/>
           <a:p>
             <a:pPr algn="l">
               <a:spcBef>
@@ -12520,7 +12396,6 @@
             <a:spAutoFit/>
           </a:bodyPr>
           <a:lstStyle/>
-          <a:p/>
           <a:p>
             <a:pPr algn="l"/>
             <a:r>
@@ -12598,7 +12473,6 @@
             <a:spAutoFit/>
           </a:bodyPr>
           <a:lstStyle/>
-          <a:p/>
           <a:p>
             <a:pPr algn="l">
               <a:spcBef>
@@ -12785,7 +12659,6 @@
             <a:spAutoFit/>
           </a:bodyPr>
           <a:lstStyle/>
-          <a:p/>
           <a:p>
             <a:pPr algn="l"/>
             <a:r>
@@ -12863,7 +12736,6 @@
             <a:spAutoFit/>
           </a:bodyPr>
           <a:lstStyle/>
-          <a:p/>
           <a:p>
             <a:pPr algn="l"/>
             <a:r>
@@ -12941,7 +12813,6 @@
             <a:spAutoFit/>
           </a:bodyPr>
           <a:lstStyle/>
-          <a:p/>
           <a:p>
             <a:pPr algn="l"/>
             <a:r>
@@ -12976,7 +12847,6 @@
             <a:spAutoFit/>
           </a:bodyPr>
           <a:lstStyle/>
-          <a:p/>
           <a:p>
             <a:pPr algn="l"/>
             <a:r>
@@ -13011,7 +12881,6 @@
             <a:spAutoFit/>
           </a:bodyPr>
           <a:lstStyle/>
-          <a:p/>
           <a:p>
             <a:pPr algn="l"/>
             <a:r>
@@ -13046,7 +12915,6 @@
             <a:spAutoFit/>
           </a:bodyPr>
           <a:lstStyle/>
-          <a:p/>
           <a:p>
             <a:pPr algn="l"/>
             <a:r>
@@ -13081,7 +12949,6 @@
             <a:spAutoFit/>
           </a:bodyPr>
           <a:lstStyle/>
-          <a:p/>
           <a:p>
             <a:pPr algn="l"/>
             <a:r>
@@ -13159,7 +13026,6 @@
             <a:spAutoFit/>
           </a:bodyPr>
           <a:lstStyle/>
-          <a:p/>
           <a:p>
             <a:pPr algn="l"/>
             <a:r>
@@ -13194,7 +13060,6 @@
             <a:spAutoFit/>
           </a:bodyPr>
           <a:lstStyle/>
-          <a:p/>
           <a:p>
             <a:pPr algn="l"/>
             <a:r>
@@ -13229,7 +13094,6 @@
             <a:spAutoFit/>
           </a:bodyPr>
           <a:lstStyle/>
-          <a:p/>
           <a:p>
             <a:pPr algn="l"/>
             <a:r>
@@ -13264,7 +13128,6 @@
             <a:spAutoFit/>
           </a:bodyPr>
           <a:lstStyle/>
-          <a:p/>
           <a:p>
             <a:pPr algn="l"/>
             <a:r>
@@ -13299,7 +13162,6 @@
             <a:spAutoFit/>
           </a:bodyPr>
           <a:lstStyle/>
-          <a:p/>
           <a:p>
             <a:pPr algn="l"/>
             <a:r>
@@ -13377,7 +13239,6 @@
             <a:spAutoFit/>
           </a:bodyPr>
           <a:lstStyle/>
-          <a:p/>
           <a:p>
             <a:pPr algn="l"/>
             <a:r>
@@ -13412,7 +13273,6 @@
             <a:spAutoFit/>
           </a:bodyPr>
           <a:lstStyle/>
-          <a:p/>
           <a:p>
             <a:pPr algn="l"/>
             <a:r>
@@ -13447,7 +13307,6 @@
             <a:spAutoFit/>
           </a:bodyPr>
           <a:lstStyle/>
-          <a:p/>
           <a:p>
             <a:pPr algn="l"/>
             <a:r>
@@ -13482,7 +13341,6 @@
             <a:spAutoFit/>
           </a:bodyPr>
           <a:lstStyle/>
-          <a:p/>
           <a:p>
             <a:pPr algn="l"/>
             <a:r>
@@ -13517,7 +13375,6 @@
             <a:spAutoFit/>
           </a:bodyPr>
           <a:lstStyle/>
-          <a:p/>
           <a:p>
             <a:pPr algn="l"/>
             <a:r>
@@ -13595,7 +13452,6 @@
             <a:spAutoFit/>
           </a:bodyPr>
           <a:lstStyle/>
-          <a:p/>
           <a:p>
             <a:pPr algn="l"/>
             <a:r>
@@ -13630,7 +13486,6 @@
             <a:spAutoFit/>
           </a:bodyPr>
           <a:lstStyle/>
-          <a:p/>
           <a:p>
             <a:pPr algn="l"/>
             <a:r>
@@ -13665,7 +13520,6 @@
             <a:spAutoFit/>
           </a:bodyPr>
           <a:lstStyle/>
-          <a:p/>
           <a:p>
             <a:pPr algn="l"/>
             <a:r>
@@ -13700,7 +13554,6 @@
             <a:spAutoFit/>
           </a:bodyPr>
           <a:lstStyle/>
-          <a:p/>
           <a:p>
             <a:pPr algn="l"/>
             <a:r>
@@ -13735,7 +13588,6 @@
             <a:spAutoFit/>
           </a:bodyPr>
           <a:lstStyle/>
-          <a:p/>
           <a:p>
             <a:pPr algn="l"/>
             <a:r>
@@ -13770,7 +13622,6 @@
             <a:spAutoFit/>
           </a:bodyPr>
           <a:lstStyle/>
-          <a:p/>
           <a:p>
             <a:pPr algn="r"/>
             <a:r>
@@ -13909,7 +13760,6 @@
             <a:spAutoFit/>
           </a:bodyPr>
           <a:lstStyle/>
-          <a:p/>
           <a:p>
             <a:pPr algn="l"/>
             <a:r>
@@ -13944,7 +13794,6 @@
             <a:spAutoFit/>
           </a:bodyPr>
           <a:lstStyle/>
-          <a:p/>
           <a:p>
             <a:pPr algn="l"/>
             <a:r>
@@ -14022,7 +13871,6 @@
             <a:spAutoFit/>
           </a:bodyPr>
           <a:lstStyle/>
-          <a:p/>
           <a:p>
             <a:pPr algn="l"/>
             <a:r>
@@ -14057,7 +13905,6 @@
             <a:spAutoFit/>
           </a:bodyPr>
           <a:lstStyle/>
-          <a:p/>
           <a:p>
             <a:pPr algn="l">
               <a:spcBef>
@@ -14214,7 +14061,6 @@
             <a:spAutoFit/>
           </a:bodyPr>
           <a:lstStyle/>
-          <a:p/>
           <a:p>
             <a:pPr algn="l"/>
             <a:r>
@@ -14292,7 +14138,6 @@
             <a:spAutoFit/>
           </a:bodyPr>
           <a:lstStyle/>
-          <a:p/>
           <a:p>
             <a:pPr algn="l">
               <a:spcBef>
@@ -14479,7 +14324,6 @@
             <a:spAutoFit/>
           </a:bodyPr>
           <a:lstStyle/>
-          <a:p/>
           <a:p>
             <a:pPr algn="l"/>
             <a:r>
@@ -14557,7 +14401,6 @@
             <a:spAutoFit/>
           </a:bodyPr>
           <a:lstStyle/>
-          <a:p/>
           <a:p>
             <a:pPr algn="l">
               <a:spcBef>
@@ -14759,7 +14602,6 @@
             <a:spAutoFit/>
           </a:bodyPr>
           <a:lstStyle/>
-          <a:p/>
           <a:p>
             <a:pPr algn="l"/>
             <a:r>
@@ -14837,7 +14679,6 @@
             <a:spAutoFit/>
           </a:bodyPr>
           <a:lstStyle/>
-          <a:p/>
           <a:p>
             <a:pPr algn="l">
               <a:spcBef>
@@ -14981,7 +14822,6 @@
             <a:spAutoFit/>
           </a:bodyPr>
           <a:lstStyle/>
-          <a:p/>
           <a:p>
             <a:pPr algn="r"/>
             <a:r>
@@ -15120,7 +14960,6 @@
             <a:spAutoFit/>
           </a:bodyPr>
           <a:lstStyle/>
-          <a:p/>
           <a:p>
             <a:pPr algn="l"/>
             <a:r>
@@ -15155,7 +14994,6 @@
             <a:spAutoFit/>
           </a:bodyPr>
           <a:lstStyle/>
-          <a:p/>
           <a:p>
             <a:pPr algn="l"/>
             <a:r>
@@ -15233,7 +15071,6 @@
             <a:spAutoFit/>
           </a:bodyPr>
           <a:lstStyle/>
-          <a:p/>
           <a:p>
             <a:pPr algn="l"/>
             <a:r>
@@ -15311,7 +15148,6 @@
             <a:spAutoFit/>
           </a:bodyPr>
           <a:lstStyle/>
-          <a:p/>
           <a:p>
             <a:pPr algn="l"/>
             <a:r>
@@ -15346,7 +15182,6 @@
             <a:spAutoFit/>
           </a:bodyPr>
           <a:lstStyle/>
-          <a:p/>
           <a:p>
             <a:pPr algn="l"/>
             <a:r>
@@ -15381,7 +15216,6 @@
             <a:spAutoFit/>
           </a:bodyPr>
           <a:lstStyle/>
-          <a:p/>
           <a:p>
             <a:pPr algn="l"/>
             <a:r>
@@ -15459,7 +15293,6 @@
             <a:spAutoFit/>
           </a:bodyPr>
           <a:lstStyle/>
-          <a:p/>
           <a:p>
             <a:pPr algn="l"/>
             <a:r>
@@ -15494,7 +15327,6 @@
             <a:spAutoFit/>
           </a:bodyPr>
           <a:lstStyle/>
-          <a:p/>
           <a:p>
             <a:pPr algn="l"/>
             <a:r>
@@ -15529,7 +15361,6 @@
             <a:spAutoFit/>
           </a:bodyPr>
           <a:lstStyle/>
-          <a:p/>
           <a:p>
             <a:pPr algn="l"/>
             <a:r>
@@ -15607,7 +15438,6 @@
             <a:spAutoFit/>
           </a:bodyPr>
           <a:lstStyle/>
-          <a:p/>
           <a:p>
             <a:pPr algn="l"/>
             <a:r>
@@ -15642,7 +15472,6 @@
             <a:spAutoFit/>
           </a:bodyPr>
           <a:lstStyle/>
-          <a:p/>
           <a:p>
             <a:pPr algn="l"/>
             <a:r>
@@ -15677,7 +15506,6 @@
             <a:spAutoFit/>
           </a:bodyPr>
           <a:lstStyle/>
-          <a:p/>
           <a:p>
             <a:pPr algn="l"/>
             <a:r>
@@ -15755,7 +15583,6 @@
             <a:spAutoFit/>
           </a:bodyPr>
           <a:lstStyle/>
-          <a:p/>
           <a:p>
             <a:pPr algn="l"/>
             <a:r>
@@ -15833,7 +15660,6 @@
             <a:spAutoFit/>
           </a:bodyPr>
           <a:lstStyle/>
-          <a:p/>
           <a:p>
             <a:pPr algn="l"/>
             <a:r>
@@ -15868,7 +15694,6 @@
             <a:spAutoFit/>
           </a:bodyPr>
           <a:lstStyle/>
-          <a:p/>
           <a:p>
             <a:pPr algn="l">
               <a:spcBef>
@@ -16130,7 +15955,6 @@
             <a:spAutoFit/>
           </a:bodyPr>
           <a:lstStyle/>
-          <a:p/>
           <a:p>
             <a:pPr algn="l"/>
             <a:r>
@@ -16165,7 +15989,6 @@
             <a:spAutoFit/>
           </a:bodyPr>
           <a:lstStyle/>
-          <a:p/>
           <a:p>
             <a:pPr algn="l">
               <a:spcBef>
@@ -16427,7 +16250,6 @@
             <a:spAutoFit/>
           </a:bodyPr>
           <a:lstStyle/>
-          <a:p/>
           <a:p>
             <a:pPr algn="ctr"/>
             <a:r>
@@ -16462,7 +16284,6 @@
             <a:spAutoFit/>
           </a:bodyPr>
           <a:lstStyle/>
-          <a:p/>
           <a:p>
             <a:pPr algn="r"/>
             <a:r>
@@ -16601,7 +16422,6 @@
             <a:spAutoFit/>
           </a:bodyPr>
           <a:lstStyle/>
-          <a:p/>
           <a:p>
             <a:pPr algn="l"/>
             <a:r>
@@ -16636,7 +16456,6 @@
             <a:spAutoFit/>
           </a:bodyPr>
           <a:lstStyle/>
-          <a:p/>
           <a:p>
             <a:pPr algn="l"/>
             <a:r>
@@ -16714,7 +16533,6 @@
             <a:spAutoFit/>
           </a:bodyPr>
           <a:lstStyle/>
-          <a:p/>
           <a:p>
             <a:pPr algn="l"/>
             <a:r>
@@ -16792,7 +16610,6 @@
             <a:spAutoFit/>
           </a:bodyPr>
           <a:lstStyle/>
-          <a:p/>
           <a:p>
             <a:pPr algn="l">
               <a:spcBef>
@@ -16934,7 +16751,6 @@
             <a:spAutoFit/>
           </a:bodyPr>
           <a:lstStyle/>
-          <a:p/>
           <a:p>
             <a:pPr algn="l"/>
             <a:r>
@@ -17012,7 +16828,6 @@
             <a:spAutoFit/>
           </a:bodyPr>
           <a:lstStyle/>
-          <a:p/>
           <a:p>
             <a:pPr algn="l">
               <a:spcBef>
@@ -17154,7 +16969,6 @@
             <a:spAutoFit/>
           </a:bodyPr>
           <a:lstStyle/>
-          <a:p/>
           <a:p>
             <a:pPr algn="l"/>
             <a:r>
@@ -17232,7 +17046,6 @@
             <a:spAutoFit/>
           </a:bodyPr>
           <a:lstStyle/>
-          <a:p/>
           <a:p>
             <a:pPr algn="l">
               <a:spcBef>
@@ -17374,7 +17187,6 @@
             <a:spAutoFit/>
           </a:bodyPr>
           <a:lstStyle/>
-          <a:p/>
           <a:p>
             <a:pPr algn="l"/>
             <a:r>
@@ -17452,7 +17264,6 @@
             <a:spAutoFit/>
           </a:bodyPr>
           <a:lstStyle/>
-          <a:p/>
           <a:p>
             <a:pPr algn="l">
               <a:spcBef>
@@ -17594,7 +17405,6 @@
             <a:spAutoFit/>
           </a:bodyPr>
           <a:lstStyle/>
-          <a:p/>
           <a:p>
             <a:pPr algn="l"/>
             <a:r>
@@ -17672,7 +17482,6 @@
             <a:spAutoFit/>
           </a:bodyPr>
           <a:lstStyle/>
-          <a:p/>
           <a:p>
             <a:pPr algn="l"/>
             <a:r>
@@ -17707,7 +17516,6 @@
             <a:spAutoFit/>
           </a:bodyPr>
           <a:lstStyle/>
-          <a:p/>
           <a:p>
             <a:pPr algn="l"/>
             <a:r>
@@ -17742,7 +17550,6 @@
             <a:spAutoFit/>
           </a:bodyPr>
           <a:lstStyle/>
-          <a:p/>
           <a:p>
             <a:pPr algn="l"/>
             <a:r>
@@ -17777,7 +17584,6 @@
             <a:spAutoFit/>
           </a:bodyPr>
           <a:lstStyle/>
-          <a:p/>
           <a:p>
             <a:pPr algn="l"/>
             <a:r>
@@ -17812,7 +17618,6 @@
             <a:spAutoFit/>
           </a:bodyPr>
           <a:lstStyle/>
-          <a:p/>
           <a:p>
             <a:pPr algn="l"/>
             <a:r>
@@ -17890,7 +17695,6 @@
             <a:spAutoFit/>
           </a:bodyPr>
           <a:lstStyle/>
-          <a:p/>
           <a:p>
             <a:pPr algn="l"/>
             <a:r>
@@ -17925,7 +17729,6 @@
             <a:spAutoFit/>
           </a:bodyPr>
           <a:lstStyle/>
-          <a:p/>
           <a:p>
             <a:pPr algn="l"/>
             <a:r>
@@ -17960,7 +17763,6 @@
             <a:spAutoFit/>
           </a:bodyPr>
           <a:lstStyle/>
-          <a:p/>
           <a:p>
             <a:pPr algn="l"/>
             <a:r>
@@ -17995,7 +17797,6 @@
             <a:spAutoFit/>
           </a:bodyPr>
           <a:lstStyle/>
-          <a:p/>
           <a:p>
             <a:pPr algn="l"/>
             <a:r>
@@ -18030,7 +17831,6 @@
             <a:spAutoFit/>
           </a:bodyPr>
           <a:lstStyle/>
-          <a:p/>
           <a:p>
             <a:pPr algn="l"/>
             <a:r>
@@ -18108,7 +17908,6 @@
             <a:spAutoFit/>
           </a:bodyPr>
           <a:lstStyle/>
-          <a:p/>
           <a:p>
             <a:pPr algn="l"/>
             <a:r>
@@ -18143,7 +17942,6 @@
             <a:spAutoFit/>
           </a:bodyPr>
           <a:lstStyle/>
-          <a:p/>
           <a:p>
             <a:pPr algn="l"/>
             <a:r>
@@ -18178,7 +17976,6 @@
             <a:spAutoFit/>
           </a:bodyPr>
           <a:lstStyle/>
-          <a:p/>
           <a:p>
             <a:pPr algn="l"/>
             <a:r>
@@ -18213,7 +18010,6 @@
             <a:spAutoFit/>
           </a:bodyPr>
           <a:lstStyle/>
-          <a:p/>
           <a:p>
             <a:pPr algn="l"/>
             <a:r>
@@ -18248,7 +18044,6 @@
             <a:spAutoFit/>
           </a:bodyPr>
           <a:lstStyle/>
-          <a:p/>
           <a:p>
             <a:pPr algn="l"/>
             <a:r>
@@ -18326,7 +18121,6 @@
             <a:spAutoFit/>
           </a:bodyPr>
           <a:lstStyle/>
-          <a:p/>
           <a:p>
             <a:pPr algn="l"/>
             <a:r>
@@ -18361,7 +18155,6 @@
             <a:spAutoFit/>
           </a:bodyPr>
           <a:lstStyle/>
-          <a:p/>
           <a:p>
             <a:pPr algn="l"/>
             <a:r>
@@ -18396,7 +18189,6 @@
             <a:spAutoFit/>
           </a:bodyPr>
           <a:lstStyle/>
-          <a:p/>
           <a:p>
             <a:pPr algn="l"/>
             <a:r>
@@ -18431,7 +18223,6 @@
             <a:spAutoFit/>
           </a:bodyPr>
           <a:lstStyle/>
-          <a:p/>
           <a:p>
             <a:pPr algn="l"/>
             <a:r>
@@ -18466,7 +18257,6 @@
             <a:spAutoFit/>
           </a:bodyPr>
           <a:lstStyle/>
-          <a:p/>
           <a:p>
             <a:pPr algn="l"/>
             <a:r>
@@ -18544,7 +18334,6 @@
             <a:spAutoFit/>
           </a:bodyPr>
           <a:lstStyle/>
-          <a:p/>
           <a:p>
             <a:pPr algn="l"/>
             <a:r>
@@ -18579,7 +18368,6 @@
             <a:spAutoFit/>
           </a:bodyPr>
           <a:lstStyle/>
-          <a:p/>
           <a:p>
             <a:pPr algn="l"/>
             <a:r>
@@ -18614,7 +18402,6 @@
             <a:spAutoFit/>
           </a:bodyPr>
           <a:lstStyle/>
-          <a:p/>
           <a:p>
             <a:pPr algn="l"/>
             <a:r>
@@ -18649,7 +18436,6 @@
             <a:spAutoFit/>
           </a:bodyPr>
           <a:lstStyle/>
-          <a:p/>
           <a:p>
             <a:pPr algn="l"/>
             <a:r>
@@ -18684,7 +18470,6 @@
             <a:spAutoFit/>
           </a:bodyPr>
           <a:lstStyle/>
-          <a:p/>
           <a:p>
             <a:pPr algn="l"/>
             <a:r>
@@ -18762,7 +18547,6 @@
             <a:spAutoFit/>
           </a:bodyPr>
           <a:lstStyle/>
-          <a:p/>
           <a:p>
             <a:pPr algn="l"/>
             <a:r>
@@ -18797,7 +18581,6 @@
             <a:spAutoFit/>
           </a:bodyPr>
           <a:lstStyle/>
-          <a:p/>
           <a:p>
             <a:pPr algn="l">
               <a:spcBef>
@@ -18836,7 +18619,6 @@
             <a:spAutoFit/>
           </a:bodyPr>
           <a:lstStyle/>
-          <a:p/>
           <a:p>
             <a:pPr algn="r"/>
             <a:r>

</xml_diff>

<commit_message>
Fix PPT layout overlaps, dark_section heights, and add HTML exam document
- Fix cfp/p() empty-paragraph bug: reuse first paragraph instead of
  adding new one, preventing invisible blank line pushing text out of bounds
- Fix dark_section content box overflow on slides 13, 15, 22, 23, 24, 28:
  shorten text to fit available height; increase s28 height to 1.10" and
  adjust assumption card positions to avoid overlap
- Fix dark2 text overflow on s22 and s25: tighten sentences to fit 0.56"
  and 0.64" content boxes respectively
- Fix slide 10 exam footer overlap (moved to y=6.68")
- Add CLINICAL_EXAM.html: self-contained styled HTML version of the writeup
- Both PPTXes audit clean (no shapes below y=6.95")

https://claude.ai/code/session_01HikGFqHKpu7poLxTbm8QFe

Co-authored-by: Claude <noreply@anthropic.com>
</commit_message>
<xml_diff>
--- a/Clinical_Note_Retrieval_Exam.pptx
+++ b/Clinical_Note_Retrieval_Exam.pptx
@@ -3204,7 +3204,6 @@
             <a:spAutoFit/>
           </a:bodyPr>
           <a:lstStyle/>
-          <a:p/>
           <a:p>
             <a:pPr algn="l"/>
             <a:r>
@@ -3239,7 +3238,6 @@
             <a:spAutoFit/>
           </a:bodyPr>
           <a:lstStyle/>
-          <a:p/>
           <a:p>
             <a:pPr algn="l"/>
             <a:r>
@@ -3274,7 +3272,6 @@
             <a:spAutoFit/>
           </a:bodyPr>
           <a:lstStyle/>
-          <a:p/>
           <a:p>
             <a:pPr algn="l"/>
             <a:r>
@@ -3395,7 +3392,6 @@
             <a:spAutoFit/>
           </a:bodyPr>
           <a:lstStyle/>
-          <a:p/>
           <a:p>
             <a:pPr algn="l"/>
             <a:r>
@@ -3430,7 +3426,6 @@
             <a:spAutoFit/>
           </a:bodyPr>
           <a:lstStyle/>
-          <a:p/>
           <a:p>
             <a:pPr algn="l"/>
             <a:r>
@@ -3508,7 +3503,6 @@
             <a:spAutoFit/>
           </a:bodyPr>
           <a:lstStyle/>
-          <a:p/>
           <a:p>
             <a:pPr algn="l"/>
             <a:r>
@@ -3543,7 +3537,6 @@
             <a:spAutoFit/>
           </a:bodyPr>
           <a:lstStyle/>
-          <a:p/>
           <a:p>
             <a:pPr algn="l"/>
             <a:r>
@@ -3621,7 +3614,6 @@
             <a:spAutoFit/>
           </a:bodyPr>
           <a:lstStyle/>
-          <a:p/>
           <a:p>
             <a:pPr algn="l"/>
             <a:r>
@@ -3656,7 +3648,6 @@
             <a:spAutoFit/>
           </a:bodyPr>
           <a:lstStyle/>
-          <a:p/>
           <a:p>
             <a:pPr algn="l"/>
             <a:r>
@@ -3734,7 +3725,6 @@
             <a:spAutoFit/>
           </a:bodyPr>
           <a:lstStyle/>
-          <a:p/>
           <a:p>
             <a:pPr algn="l"/>
             <a:r>
@@ -3769,7 +3759,6 @@
             <a:spAutoFit/>
           </a:bodyPr>
           <a:lstStyle/>
-          <a:p/>
           <a:p>
             <a:pPr algn="l"/>
             <a:r>
@@ -3804,7 +3793,6 @@
             <a:spAutoFit/>
           </a:bodyPr>
           <a:lstStyle/>
-          <a:p/>
           <a:p>
             <a:pPr algn="l"/>
             <a:r>
@@ -3839,7 +3827,6 @@
             <a:spAutoFit/>
           </a:bodyPr>
           <a:lstStyle/>
-          <a:p/>
           <a:p>
             <a:pPr algn="l"/>
             <a:r>
@@ -3874,7 +3861,6 @@
             <a:spAutoFit/>
           </a:bodyPr>
           <a:lstStyle/>
-          <a:p/>
           <a:p>
             <a:pPr algn="l"/>
             <a:r>
@@ -3909,7 +3895,6 @@
             <a:spAutoFit/>
           </a:bodyPr>
           <a:lstStyle/>
-          <a:p/>
           <a:p>
             <a:pPr algn="l"/>
             <a:r>
@@ -3944,7 +3929,6 @@
             <a:spAutoFit/>
           </a:bodyPr>
           <a:lstStyle/>
-          <a:p/>
           <a:p>
             <a:pPr algn="l"/>
             <a:r>
@@ -3979,7 +3963,6 @@
             <a:spAutoFit/>
           </a:bodyPr>
           <a:lstStyle/>
-          <a:p/>
           <a:p>
             <a:pPr algn="l"/>
             <a:r>
@@ -4014,7 +3997,6 @@
             <a:spAutoFit/>
           </a:bodyPr>
           <a:lstStyle/>
-          <a:p/>
           <a:p>
             <a:pPr algn="l"/>
             <a:r>
@@ -4049,7 +4031,6 @@
             <a:spAutoFit/>
           </a:bodyPr>
           <a:lstStyle/>
-          <a:p/>
           <a:p>
             <a:pPr algn="l"/>
             <a:r>
@@ -4084,7 +4065,6 @@
             <a:spAutoFit/>
           </a:bodyPr>
           <a:lstStyle/>
-          <a:p/>
           <a:p>
             <a:pPr algn="l"/>
             <a:r>
@@ -4119,7 +4099,6 @@
             <a:spAutoFit/>
           </a:bodyPr>
           <a:lstStyle/>
-          <a:p/>
           <a:p>
             <a:pPr algn="l"/>
             <a:r>
@@ -4154,7 +4133,6 @@
             <a:spAutoFit/>
           </a:bodyPr>
           <a:lstStyle/>
-          <a:p/>
           <a:p>
             <a:pPr algn="r"/>
             <a:r>
@@ -4293,7 +4271,6 @@
             <a:spAutoFit/>
           </a:bodyPr>
           <a:lstStyle/>
-          <a:p/>
           <a:p>
             <a:pPr algn="l"/>
             <a:r>
@@ -4371,7 +4348,6 @@
             <a:spAutoFit/>
           </a:bodyPr>
           <a:lstStyle/>
-          <a:p/>
           <a:p>
             <a:pPr algn="l"/>
             <a:r>
@@ -4406,7 +4382,6 @@
             <a:spAutoFit/>
           </a:bodyPr>
           <a:lstStyle/>
-          <a:p/>
           <a:p>
             <a:pPr algn="l">
               <a:spcBef>
@@ -4668,7 +4643,6 @@
             <a:spAutoFit/>
           </a:bodyPr>
           <a:lstStyle/>
-          <a:p/>
           <a:p>
             <a:pPr algn="l"/>
             <a:r>
@@ -4703,7 +4677,6 @@
             <a:spAutoFit/>
           </a:bodyPr>
           <a:lstStyle/>
-          <a:p/>
           <a:p>
             <a:pPr algn="l">
               <a:spcBef>
@@ -4924,20 +4897,19 @@
         </p:nvSpPr>
         <p:spPr>
           <a:xfrm>
-            <a:off x="411480" y="6190488"/>
-            <a:ext cx="11430000" cy="201168"/>
-          </a:xfrm>
-          <a:prstGeom prst="rect">
-            <a:avLst/>
-          </a:prstGeom>
-          <a:noFill/>
-        </p:spPr>
-        <p:txBody>
-          <a:bodyPr wrap="square">
-            <a:spAutoFit/>
-          </a:bodyPr>
-          <a:lstStyle/>
-          <a:p/>
+            <a:off x="411480" y="6108192"/>
+            <a:ext cx="11430000" cy="182880"/>
+          </a:xfrm>
+          <a:prstGeom prst="rect">
+            <a:avLst/>
+          </a:prstGeom>
+          <a:noFill/>
+        </p:spPr>
+        <p:txBody>
+          <a:bodyPr wrap="square">
+            <a:spAutoFit/>
+          </a:bodyPr>
+          <a:lstStyle/>
           <a:p>
             <a:pPr algn="ctr"/>
             <a:r>
@@ -4972,7 +4944,6 @@
             <a:spAutoFit/>
           </a:bodyPr>
           <a:lstStyle/>
-          <a:p/>
           <a:p>
             <a:pPr algn="r"/>
             <a:r>
@@ -5111,7 +5082,6 @@
             <a:spAutoFit/>
           </a:bodyPr>
           <a:lstStyle/>
-          <a:p/>
           <a:p>
             <a:pPr algn="l"/>
             <a:r>
@@ -5146,7 +5116,6 @@
             <a:spAutoFit/>
           </a:bodyPr>
           <a:lstStyle/>
-          <a:p/>
           <a:p>
             <a:pPr algn="l"/>
             <a:r>
@@ -5224,7 +5193,6 @@
             <a:spAutoFit/>
           </a:bodyPr>
           <a:lstStyle/>
-          <a:p/>
           <a:p>
             <a:pPr algn="l"/>
             <a:r>
@@ -5302,7 +5270,6 @@
             <a:spAutoFit/>
           </a:bodyPr>
           <a:lstStyle/>
-          <a:p/>
           <a:p>
             <a:pPr algn="l">
               <a:spcBef>
@@ -5534,7 +5501,6 @@
             <a:spAutoFit/>
           </a:bodyPr>
           <a:lstStyle/>
-          <a:p/>
           <a:p>
             <a:pPr algn="l"/>
             <a:r>
@@ -5612,7 +5578,6 @@
             <a:spAutoFit/>
           </a:bodyPr>
           <a:lstStyle/>
-          <a:p/>
           <a:p>
             <a:pPr algn="l">
               <a:spcBef>
@@ -5829,7 +5794,6 @@
             <a:spAutoFit/>
           </a:bodyPr>
           <a:lstStyle/>
-          <a:p/>
           <a:p>
             <a:pPr algn="l"/>
             <a:r>
@@ -5864,7 +5828,6 @@
             <a:spAutoFit/>
           </a:bodyPr>
           <a:lstStyle/>
-          <a:p/>
           <a:p>
             <a:pPr algn="l"/>
             <a:r>
@@ -5899,7 +5862,6 @@
             <a:spAutoFit/>
           </a:bodyPr>
           <a:lstStyle/>
-          <a:p/>
           <a:p>
             <a:pPr algn="l"/>
             <a:r>
@@ -5934,7 +5896,6 @@
             <a:spAutoFit/>
           </a:bodyPr>
           <a:lstStyle/>
-          <a:p/>
           <a:p>
             <a:pPr algn="l"/>
             <a:r>
@@ -5969,7 +5930,6 @@
             <a:spAutoFit/>
           </a:bodyPr>
           <a:lstStyle/>
-          <a:p/>
           <a:p>
             <a:pPr algn="r"/>
             <a:r>
@@ -6108,7 +6068,6 @@
             <a:spAutoFit/>
           </a:bodyPr>
           <a:lstStyle/>
-          <a:p/>
           <a:p>
             <a:pPr algn="l"/>
             <a:r>
@@ -6143,7 +6102,6 @@
             <a:spAutoFit/>
           </a:bodyPr>
           <a:lstStyle/>
-          <a:p/>
           <a:p>
             <a:pPr algn="l"/>
             <a:r>
@@ -6221,7 +6179,6 @@
             <a:spAutoFit/>
           </a:bodyPr>
           <a:lstStyle/>
-          <a:p/>
           <a:p>
             <a:pPr algn="l"/>
             <a:r>
@@ -6299,7 +6256,6 @@
             <a:spAutoFit/>
           </a:bodyPr>
           <a:lstStyle/>
-          <a:p/>
           <a:p>
             <a:pPr algn="l">
               <a:spcBef>
@@ -6441,7 +6397,6 @@
             <a:spAutoFit/>
           </a:bodyPr>
           <a:lstStyle/>
-          <a:p/>
           <a:p>
             <a:pPr algn="l"/>
             <a:r>
@@ -6519,7 +6474,6 @@
             <a:spAutoFit/>
           </a:bodyPr>
           <a:lstStyle/>
-          <a:p/>
           <a:p>
             <a:pPr algn="l">
               <a:spcBef>
@@ -6661,7 +6615,6 @@
             <a:spAutoFit/>
           </a:bodyPr>
           <a:lstStyle/>
-          <a:p/>
           <a:p>
             <a:pPr algn="l"/>
             <a:r>
@@ -6739,7 +6692,6 @@
             <a:spAutoFit/>
           </a:bodyPr>
           <a:lstStyle/>
-          <a:p/>
           <a:p>
             <a:pPr algn="l">
               <a:spcBef>
@@ -6881,7 +6833,6 @@
             <a:spAutoFit/>
           </a:bodyPr>
           <a:lstStyle/>
-          <a:p/>
           <a:p>
             <a:pPr algn="l"/>
             <a:r>
@@ -6959,7 +6910,6 @@
             <a:spAutoFit/>
           </a:bodyPr>
           <a:lstStyle/>
-          <a:p/>
           <a:p>
             <a:pPr algn="l">
               <a:spcBef>
@@ -7101,7 +7051,6 @@
             <a:spAutoFit/>
           </a:bodyPr>
           <a:lstStyle/>
-          <a:p/>
           <a:p>
             <a:pPr algn="l"/>
             <a:r>
@@ -7136,7 +7085,6 @@
             <a:spAutoFit/>
           </a:bodyPr>
           <a:lstStyle/>
-          <a:p/>
           <a:p>
             <a:pPr algn="l"/>
             <a:r>
@@ -7214,7 +7162,6 @@
             <a:spAutoFit/>
           </a:bodyPr>
           <a:lstStyle/>
-          <a:p/>
           <a:p>
             <a:pPr algn="l"/>
             <a:r>
@@ -7292,7 +7239,6 @@
             <a:spAutoFit/>
           </a:bodyPr>
           <a:lstStyle/>
-          <a:p/>
           <a:p>
             <a:pPr algn="l"/>
             <a:r>
@@ -7327,7 +7273,6 @@
             <a:spAutoFit/>
           </a:bodyPr>
           <a:lstStyle/>
-          <a:p/>
           <a:p>
             <a:pPr algn="l"/>
             <a:r>
@@ -7362,7 +7307,6 @@
             <a:spAutoFit/>
           </a:bodyPr>
           <a:lstStyle/>
-          <a:p/>
           <a:p>
             <a:pPr algn="l"/>
             <a:r>
@@ -7440,7 +7384,6 @@
             <a:spAutoFit/>
           </a:bodyPr>
           <a:lstStyle/>
-          <a:p/>
           <a:p>
             <a:pPr algn="l"/>
             <a:r>
@@ -7475,7 +7418,6 @@
             <a:spAutoFit/>
           </a:bodyPr>
           <a:lstStyle/>
-          <a:p/>
           <a:p>
             <a:pPr algn="l"/>
             <a:r>
@@ -7510,7 +7452,6 @@
             <a:spAutoFit/>
           </a:bodyPr>
           <a:lstStyle/>
-          <a:p/>
           <a:p>
             <a:pPr algn="l"/>
             <a:r>
@@ -7588,7 +7529,6 @@
             <a:spAutoFit/>
           </a:bodyPr>
           <a:lstStyle/>
-          <a:p/>
           <a:p>
             <a:pPr algn="l"/>
             <a:r>
@@ -7623,7 +7563,6 @@
             <a:spAutoFit/>
           </a:bodyPr>
           <a:lstStyle/>
-          <a:p/>
           <a:p>
             <a:pPr algn="l"/>
             <a:r>
@@ -7658,7 +7597,6 @@
             <a:spAutoFit/>
           </a:bodyPr>
           <a:lstStyle/>
-          <a:p/>
           <a:p>
             <a:pPr algn="l"/>
             <a:r>
@@ -7736,7 +7674,6 @@
             <a:spAutoFit/>
           </a:bodyPr>
           <a:lstStyle/>
-          <a:p/>
           <a:p>
             <a:pPr algn="l"/>
             <a:r>
@@ -7771,7 +7708,6 @@
             <a:spAutoFit/>
           </a:bodyPr>
           <a:lstStyle/>
-          <a:p/>
           <a:p>
             <a:pPr algn="l"/>
             <a:r>
@@ -7806,7 +7742,6 @@
             <a:spAutoFit/>
           </a:bodyPr>
           <a:lstStyle/>
-          <a:p/>
           <a:p>
             <a:pPr algn="l"/>
             <a:r>
@@ -7884,7 +7819,6 @@
             <a:spAutoFit/>
           </a:bodyPr>
           <a:lstStyle/>
-          <a:p/>
           <a:p>
             <a:pPr algn="l"/>
             <a:r>
@@ -7919,7 +7853,6 @@
             <a:spAutoFit/>
           </a:bodyPr>
           <a:lstStyle/>
-          <a:p/>
           <a:p>
             <a:pPr algn="l"/>
             <a:r>
@@ -7954,7 +7887,6 @@
             <a:spAutoFit/>
           </a:bodyPr>
           <a:lstStyle/>
-          <a:p/>
           <a:p>
             <a:pPr algn="l"/>
             <a:r>
@@ -7989,7 +7921,6 @@
             <a:spAutoFit/>
           </a:bodyPr>
           <a:lstStyle/>
-          <a:p/>
           <a:p>
             <a:pPr algn="l"/>
             <a:r>
@@ -8024,7 +7955,6 @@
             <a:spAutoFit/>
           </a:bodyPr>
           <a:lstStyle/>
-          <a:p/>
           <a:p>
             <a:pPr algn="r"/>
             <a:r>
@@ -8163,7 +8093,6 @@
             <a:spAutoFit/>
           </a:bodyPr>
           <a:lstStyle/>
-          <a:p/>
           <a:p>
             <a:pPr algn="l"/>
             <a:r>
@@ -8198,7 +8127,6 @@
             <a:spAutoFit/>
           </a:bodyPr>
           <a:lstStyle/>
-          <a:p/>
           <a:p>
             <a:pPr algn="l"/>
             <a:r>
@@ -8276,7 +8204,6 @@
             <a:spAutoFit/>
           </a:bodyPr>
           <a:lstStyle/>
-          <a:p/>
           <a:p>
             <a:pPr algn="l"/>
             <a:r>
@@ -8354,7 +8281,6 @@
             <a:spAutoFit/>
           </a:bodyPr>
           <a:lstStyle/>
-          <a:p/>
           <a:p>
             <a:pPr algn="l">
               <a:spcBef>
@@ -8438,7 +8364,6 @@
             <a:spAutoFit/>
           </a:bodyPr>
           <a:lstStyle/>
-          <a:p/>
           <a:p>
             <a:pPr algn="l"/>
             <a:r>
@@ -8516,7 +8441,6 @@
             <a:spAutoFit/>
           </a:bodyPr>
           <a:lstStyle/>
-          <a:p/>
           <a:p>
             <a:pPr algn="l"/>
             <a:r>
@@ -8594,7 +8518,6 @@
             <a:spAutoFit/>
           </a:bodyPr>
           <a:lstStyle/>
-          <a:p/>
           <a:p>
             <a:pPr algn="l">
               <a:spcBef>
@@ -8678,7 +8601,6 @@
             <a:spAutoFit/>
           </a:bodyPr>
           <a:lstStyle/>
-          <a:p/>
           <a:p>
             <a:pPr algn="l"/>
             <a:r>
@@ -8756,7 +8678,6 @@
             <a:spAutoFit/>
           </a:bodyPr>
           <a:lstStyle/>
-          <a:p/>
           <a:p>
             <a:pPr algn="l"/>
             <a:r>
@@ -8834,7 +8755,6 @@
             <a:spAutoFit/>
           </a:bodyPr>
           <a:lstStyle/>
-          <a:p/>
           <a:p>
             <a:pPr algn="l">
               <a:spcBef>
@@ -8918,7 +8838,6 @@
             <a:spAutoFit/>
           </a:bodyPr>
           <a:lstStyle/>
-          <a:p/>
           <a:p>
             <a:pPr algn="l"/>
             <a:r>
@@ -8996,7 +8915,6 @@
             <a:spAutoFit/>
           </a:bodyPr>
           <a:lstStyle/>
-          <a:p/>
           <a:p>
             <a:pPr algn="l"/>
             <a:r>
@@ -9074,7 +8992,6 @@
             <a:spAutoFit/>
           </a:bodyPr>
           <a:lstStyle/>
-          <a:p/>
           <a:p>
             <a:pPr algn="l">
               <a:spcBef>
@@ -9158,7 +9075,6 @@
             <a:spAutoFit/>
           </a:bodyPr>
           <a:lstStyle/>
-          <a:p/>
           <a:p>
             <a:pPr algn="l"/>
             <a:r>
@@ -9236,7 +9152,6 @@
             <a:spAutoFit/>
           </a:bodyPr>
           <a:lstStyle/>
-          <a:p/>
           <a:p>
             <a:pPr algn="l"/>
             <a:r>
@@ -9314,7 +9229,6 @@
             <a:spAutoFit/>
           </a:bodyPr>
           <a:lstStyle/>
-          <a:p/>
           <a:p>
             <a:pPr algn="l">
               <a:spcBef>
@@ -9441,7 +9355,6 @@
             <a:spAutoFit/>
           </a:bodyPr>
           <a:lstStyle/>
-          <a:p/>
           <a:p>
             <a:pPr algn="l"/>
             <a:r>
@@ -9476,7 +9389,6 @@
             <a:spAutoFit/>
           </a:bodyPr>
           <a:lstStyle/>
-          <a:p/>
           <a:p>
             <a:pPr algn="l">
               <a:spcBef>
@@ -9648,7 +9560,6 @@
             <a:spAutoFit/>
           </a:bodyPr>
           <a:lstStyle/>
-          <a:p/>
           <a:p>
             <a:pPr algn="l"/>
             <a:r>
@@ -9683,7 +9594,6 @@
             <a:spAutoFit/>
           </a:bodyPr>
           <a:lstStyle/>
-          <a:p/>
           <a:p>
             <a:pPr algn="l">
               <a:spcBef>
@@ -9812,7 +9722,6 @@
             <a:spAutoFit/>
           </a:bodyPr>
           <a:lstStyle/>
-          <a:p/>
           <a:p>
             <a:pPr algn="r"/>
             <a:r>
@@ -9951,7 +9860,6 @@
             <a:spAutoFit/>
           </a:bodyPr>
           <a:lstStyle/>
-          <a:p/>
           <a:p>
             <a:pPr algn="l"/>
             <a:r>
@@ -9986,7 +9894,6 @@
             <a:spAutoFit/>
           </a:bodyPr>
           <a:lstStyle/>
-          <a:p/>
           <a:p>
             <a:pPr algn="l"/>
             <a:r>
@@ -10064,7 +9971,6 @@
             <a:spAutoFit/>
           </a:bodyPr>
           <a:lstStyle/>
-          <a:p/>
           <a:p>
             <a:pPr algn="l"/>
             <a:r>
@@ -10185,7 +10091,6 @@
             <a:spAutoFit/>
           </a:bodyPr>
           <a:lstStyle/>
-          <a:p/>
           <a:p>
             <a:pPr algn="l"/>
             <a:r>
@@ -10220,7 +10125,6 @@
             <a:spAutoFit/>
           </a:bodyPr>
           <a:lstStyle/>
-          <a:p/>
           <a:p>
             <a:pPr algn="ctr"/>
             <a:r>
@@ -10255,7 +10159,6 @@
             <a:spAutoFit/>
           </a:bodyPr>
           <a:lstStyle/>
-          <a:p/>
           <a:p>
             <a:pPr algn="l"/>
             <a:r>
@@ -10290,7 +10193,6 @@
             <a:spAutoFit/>
           </a:bodyPr>
           <a:lstStyle/>
-          <a:p/>
           <a:p>
             <a:pPr algn="l"/>
             <a:r>
@@ -10325,7 +10227,6 @@
             <a:spAutoFit/>
           </a:bodyPr>
           <a:lstStyle/>
-          <a:p/>
           <a:p>
             <a:pPr algn="l"/>
             <a:r>
@@ -10446,7 +10347,6 @@
             <a:spAutoFit/>
           </a:bodyPr>
           <a:lstStyle/>
-          <a:p/>
           <a:p>
             <a:pPr algn="l"/>
             <a:r>
@@ -10481,7 +10381,6 @@
             <a:spAutoFit/>
           </a:bodyPr>
           <a:lstStyle/>
-          <a:p/>
           <a:p>
             <a:pPr algn="ctr"/>
             <a:r>
@@ -10516,7 +10415,6 @@
             <a:spAutoFit/>
           </a:bodyPr>
           <a:lstStyle/>
-          <a:p/>
           <a:p>
             <a:pPr algn="l"/>
             <a:r>
@@ -10551,7 +10449,6 @@
             <a:spAutoFit/>
           </a:bodyPr>
           <a:lstStyle/>
-          <a:p/>
           <a:p>
             <a:pPr algn="l"/>
             <a:r>
@@ -10586,7 +10483,6 @@
             <a:spAutoFit/>
           </a:bodyPr>
           <a:lstStyle/>
-          <a:p/>
           <a:p>
             <a:pPr algn="l"/>
             <a:r>
@@ -10707,7 +10603,6 @@
             <a:spAutoFit/>
           </a:bodyPr>
           <a:lstStyle/>
-          <a:p/>
           <a:p>
             <a:pPr algn="l"/>
             <a:r>
@@ -10742,7 +10637,6 @@
             <a:spAutoFit/>
           </a:bodyPr>
           <a:lstStyle/>
-          <a:p/>
           <a:p>
             <a:pPr algn="ctr"/>
             <a:r>
@@ -10777,7 +10671,6 @@
             <a:spAutoFit/>
           </a:bodyPr>
           <a:lstStyle/>
-          <a:p/>
           <a:p>
             <a:pPr algn="l"/>
             <a:r>
@@ -10812,7 +10705,6 @@
             <a:spAutoFit/>
           </a:bodyPr>
           <a:lstStyle/>
-          <a:p/>
           <a:p>
             <a:pPr algn="l"/>
             <a:r>
@@ -10847,7 +10739,6 @@
             <a:spAutoFit/>
           </a:bodyPr>
           <a:lstStyle/>
-          <a:p/>
           <a:p>
             <a:pPr algn="l"/>
             <a:r>
@@ -10925,7 +10816,6 @@
             <a:spAutoFit/>
           </a:bodyPr>
           <a:lstStyle/>
-          <a:p/>
           <a:p>
             <a:pPr algn="l"/>
             <a:r>
@@ -10960,7 +10850,6 @@
             <a:spAutoFit/>
           </a:bodyPr>
           <a:lstStyle/>
-          <a:p/>
           <a:p>
             <a:pPr algn="l">
               <a:spcBef>
@@ -11102,7 +10991,6 @@
             <a:spAutoFit/>
           </a:bodyPr>
           <a:lstStyle/>
-          <a:p/>
           <a:p>
             <a:pPr algn="l"/>
             <a:r>
@@ -11137,7 +11025,6 @@
             <a:spAutoFit/>
           </a:bodyPr>
           <a:lstStyle/>
-          <a:p/>
           <a:p>
             <a:pPr algn="l">
               <a:spcBef>
@@ -11279,7 +11166,6 @@
             <a:spAutoFit/>
           </a:bodyPr>
           <a:lstStyle/>
-          <a:p/>
           <a:p>
             <a:pPr algn="l"/>
             <a:r>
@@ -11357,7 +11243,6 @@
             <a:spAutoFit/>
           </a:bodyPr>
           <a:lstStyle/>
-          <a:p/>
           <a:p>
             <a:pPr algn="l">
               <a:spcBef>
@@ -11514,7 +11399,6 @@
             <a:spAutoFit/>
           </a:bodyPr>
           <a:lstStyle/>
-          <a:p/>
           <a:p>
             <a:pPr algn="l"/>
             <a:r>
@@ -11592,7 +11476,6 @@
             <a:spAutoFit/>
           </a:bodyPr>
           <a:lstStyle/>
-          <a:p/>
           <a:p>
             <a:pPr algn="l">
               <a:spcBef>
@@ -11749,7 +11632,6 @@
             <a:spAutoFit/>
           </a:bodyPr>
           <a:lstStyle/>
-          <a:p/>
           <a:p>
             <a:pPr algn="l"/>
             <a:r>
@@ -11827,7 +11709,6 @@
             <a:spAutoFit/>
           </a:bodyPr>
           <a:lstStyle/>
-          <a:p/>
           <a:p>
             <a:pPr algn="l">
               <a:spcBef>
@@ -11941,7 +11822,6 @@
             <a:spAutoFit/>
           </a:bodyPr>
           <a:lstStyle/>
-          <a:p/>
           <a:p>
             <a:pPr algn="r"/>
             <a:r>
@@ -12080,7 +11960,6 @@
             <a:spAutoFit/>
           </a:bodyPr>
           <a:lstStyle/>
-          <a:p/>
           <a:p>
             <a:pPr algn="l"/>
             <a:r>
@@ -12115,7 +11994,6 @@
             <a:spAutoFit/>
           </a:bodyPr>
           <a:lstStyle/>
-          <a:p/>
           <a:p>
             <a:pPr algn="l"/>
             <a:r>
@@ -12193,7 +12071,6 @@
             <a:spAutoFit/>
           </a:bodyPr>
           <a:lstStyle/>
-          <a:p/>
           <a:p>
             <a:pPr algn="l"/>
             <a:r>
@@ -12228,7 +12105,6 @@
             <a:spAutoFit/>
           </a:bodyPr>
           <a:lstStyle/>
-          <a:p/>
           <a:p>
             <a:pPr algn="l">
               <a:spcBef>
@@ -12520,7 +12396,6 @@
             <a:spAutoFit/>
           </a:bodyPr>
           <a:lstStyle/>
-          <a:p/>
           <a:p>
             <a:pPr algn="l"/>
             <a:r>
@@ -12598,7 +12473,6 @@
             <a:spAutoFit/>
           </a:bodyPr>
           <a:lstStyle/>
-          <a:p/>
           <a:p>
             <a:pPr algn="l">
               <a:spcBef>
@@ -12785,7 +12659,6 @@
             <a:spAutoFit/>
           </a:bodyPr>
           <a:lstStyle/>
-          <a:p/>
           <a:p>
             <a:pPr algn="l"/>
             <a:r>
@@ -12863,7 +12736,6 @@
             <a:spAutoFit/>
           </a:bodyPr>
           <a:lstStyle/>
-          <a:p/>
           <a:p>
             <a:pPr algn="l"/>
             <a:r>
@@ -12941,7 +12813,6 @@
             <a:spAutoFit/>
           </a:bodyPr>
           <a:lstStyle/>
-          <a:p/>
           <a:p>
             <a:pPr algn="l"/>
             <a:r>
@@ -12976,7 +12847,6 @@
             <a:spAutoFit/>
           </a:bodyPr>
           <a:lstStyle/>
-          <a:p/>
           <a:p>
             <a:pPr algn="l"/>
             <a:r>
@@ -13011,7 +12881,6 @@
             <a:spAutoFit/>
           </a:bodyPr>
           <a:lstStyle/>
-          <a:p/>
           <a:p>
             <a:pPr algn="l"/>
             <a:r>
@@ -13046,7 +12915,6 @@
             <a:spAutoFit/>
           </a:bodyPr>
           <a:lstStyle/>
-          <a:p/>
           <a:p>
             <a:pPr algn="l"/>
             <a:r>
@@ -13081,7 +12949,6 @@
             <a:spAutoFit/>
           </a:bodyPr>
           <a:lstStyle/>
-          <a:p/>
           <a:p>
             <a:pPr algn="l"/>
             <a:r>
@@ -13159,7 +13026,6 @@
             <a:spAutoFit/>
           </a:bodyPr>
           <a:lstStyle/>
-          <a:p/>
           <a:p>
             <a:pPr algn="l"/>
             <a:r>
@@ -13194,7 +13060,6 @@
             <a:spAutoFit/>
           </a:bodyPr>
           <a:lstStyle/>
-          <a:p/>
           <a:p>
             <a:pPr algn="l"/>
             <a:r>
@@ -13229,7 +13094,6 @@
             <a:spAutoFit/>
           </a:bodyPr>
           <a:lstStyle/>
-          <a:p/>
           <a:p>
             <a:pPr algn="l"/>
             <a:r>
@@ -13264,7 +13128,6 @@
             <a:spAutoFit/>
           </a:bodyPr>
           <a:lstStyle/>
-          <a:p/>
           <a:p>
             <a:pPr algn="l"/>
             <a:r>
@@ -13299,7 +13162,6 @@
             <a:spAutoFit/>
           </a:bodyPr>
           <a:lstStyle/>
-          <a:p/>
           <a:p>
             <a:pPr algn="l"/>
             <a:r>
@@ -13377,7 +13239,6 @@
             <a:spAutoFit/>
           </a:bodyPr>
           <a:lstStyle/>
-          <a:p/>
           <a:p>
             <a:pPr algn="l"/>
             <a:r>
@@ -13412,7 +13273,6 @@
             <a:spAutoFit/>
           </a:bodyPr>
           <a:lstStyle/>
-          <a:p/>
           <a:p>
             <a:pPr algn="l"/>
             <a:r>
@@ -13447,7 +13307,6 @@
             <a:spAutoFit/>
           </a:bodyPr>
           <a:lstStyle/>
-          <a:p/>
           <a:p>
             <a:pPr algn="l"/>
             <a:r>
@@ -13482,7 +13341,6 @@
             <a:spAutoFit/>
           </a:bodyPr>
           <a:lstStyle/>
-          <a:p/>
           <a:p>
             <a:pPr algn="l"/>
             <a:r>
@@ -13517,7 +13375,6 @@
             <a:spAutoFit/>
           </a:bodyPr>
           <a:lstStyle/>
-          <a:p/>
           <a:p>
             <a:pPr algn="l"/>
             <a:r>
@@ -13595,7 +13452,6 @@
             <a:spAutoFit/>
           </a:bodyPr>
           <a:lstStyle/>
-          <a:p/>
           <a:p>
             <a:pPr algn="l"/>
             <a:r>
@@ -13630,7 +13486,6 @@
             <a:spAutoFit/>
           </a:bodyPr>
           <a:lstStyle/>
-          <a:p/>
           <a:p>
             <a:pPr algn="l"/>
             <a:r>
@@ -13665,7 +13520,6 @@
             <a:spAutoFit/>
           </a:bodyPr>
           <a:lstStyle/>
-          <a:p/>
           <a:p>
             <a:pPr algn="l"/>
             <a:r>
@@ -13700,7 +13554,6 @@
             <a:spAutoFit/>
           </a:bodyPr>
           <a:lstStyle/>
-          <a:p/>
           <a:p>
             <a:pPr algn="l"/>
             <a:r>
@@ -13735,7 +13588,6 @@
             <a:spAutoFit/>
           </a:bodyPr>
           <a:lstStyle/>
-          <a:p/>
           <a:p>
             <a:pPr algn="l"/>
             <a:r>
@@ -13770,7 +13622,6 @@
             <a:spAutoFit/>
           </a:bodyPr>
           <a:lstStyle/>
-          <a:p/>
           <a:p>
             <a:pPr algn="r"/>
             <a:r>
@@ -13909,7 +13760,6 @@
             <a:spAutoFit/>
           </a:bodyPr>
           <a:lstStyle/>
-          <a:p/>
           <a:p>
             <a:pPr algn="l"/>
             <a:r>
@@ -13944,7 +13794,6 @@
             <a:spAutoFit/>
           </a:bodyPr>
           <a:lstStyle/>
-          <a:p/>
           <a:p>
             <a:pPr algn="l"/>
             <a:r>
@@ -14022,7 +13871,6 @@
             <a:spAutoFit/>
           </a:bodyPr>
           <a:lstStyle/>
-          <a:p/>
           <a:p>
             <a:pPr algn="l"/>
             <a:r>
@@ -14057,7 +13905,6 @@
             <a:spAutoFit/>
           </a:bodyPr>
           <a:lstStyle/>
-          <a:p/>
           <a:p>
             <a:pPr algn="l">
               <a:spcBef>
@@ -14214,7 +14061,6 @@
             <a:spAutoFit/>
           </a:bodyPr>
           <a:lstStyle/>
-          <a:p/>
           <a:p>
             <a:pPr algn="l"/>
             <a:r>
@@ -14292,7 +14138,6 @@
             <a:spAutoFit/>
           </a:bodyPr>
           <a:lstStyle/>
-          <a:p/>
           <a:p>
             <a:pPr algn="l">
               <a:spcBef>
@@ -14479,7 +14324,6 @@
             <a:spAutoFit/>
           </a:bodyPr>
           <a:lstStyle/>
-          <a:p/>
           <a:p>
             <a:pPr algn="l"/>
             <a:r>
@@ -14557,7 +14401,6 @@
             <a:spAutoFit/>
           </a:bodyPr>
           <a:lstStyle/>
-          <a:p/>
           <a:p>
             <a:pPr algn="l">
               <a:spcBef>
@@ -14759,7 +14602,6 @@
             <a:spAutoFit/>
           </a:bodyPr>
           <a:lstStyle/>
-          <a:p/>
           <a:p>
             <a:pPr algn="l"/>
             <a:r>
@@ -14837,7 +14679,6 @@
             <a:spAutoFit/>
           </a:bodyPr>
           <a:lstStyle/>
-          <a:p/>
           <a:p>
             <a:pPr algn="l">
               <a:spcBef>
@@ -14981,7 +14822,6 @@
             <a:spAutoFit/>
           </a:bodyPr>
           <a:lstStyle/>
-          <a:p/>
           <a:p>
             <a:pPr algn="r"/>
             <a:r>
@@ -15120,7 +14960,6 @@
             <a:spAutoFit/>
           </a:bodyPr>
           <a:lstStyle/>
-          <a:p/>
           <a:p>
             <a:pPr algn="l"/>
             <a:r>
@@ -15155,7 +14994,6 @@
             <a:spAutoFit/>
           </a:bodyPr>
           <a:lstStyle/>
-          <a:p/>
           <a:p>
             <a:pPr algn="l"/>
             <a:r>
@@ -15233,7 +15071,6 @@
             <a:spAutoFit/>
           </a:bodyPr>
           <a:lstStyle/>
-          <a:p/>
           <a:p>
             <a:pPr algn="l"/>
             <a:r>
@@ -15311,7 +15148,6 @@
             <a:spAutoFit/>
           </a:bodyPr>
           <a:lstStyle/>
-          <a:p/>
           <a:p>
             <a:pPr algn="l"/>
             <a:r>
@@ -15346,7 +15182,6 @@
             <a:spAutoFit/>
           </a:bodyPr>
           <a:lstStyle/>
-          <a:p/>
           <a:p>
             <a:pPr algn="l"/>
             <a:r>
@@ -15381,7 +15216,6 @@
             <a:spAutoFit/>
           </a:bodyPr>
           <a:lstStyle/>
-          <a:p/>
           <a:p>
             <a:pPr algn="l"/>
             <a:r>
@@ -15459,7 +15293,6 @@
             <a:spAutoFit/>
           </a:bodyPr>
           <a:lstStyle/>
-          <a:p/>
           <a:p>
             <a:pPr algn="l"/>
             <a:r>
@@ -15494,7 +15327,6 @@
             <a:spAutoFit/>
           </a:bodyPr>
           <a:lstStyle/>
-          <a:p/>
           <a:p>
             <a:pPr algn="l"/>
             <a:r>
@@ -15529,7 +15361,6 @@
             <a:spAutoFit/>
           </a:bodyPr>
           <a:lstStyle/>
-          <a:p/>
           <a:p>
             <a:pPr algn="l"/>
             <a:r>
@@ -15607,7 +15438,6 @@
             <a:spAutoFit/>
           </a:bodyPr>
           <a:lstStyle/>
-          <a:p/>
           <a:p>
             <a:pPr algn="l"/>
             <a:r>
@@ -15642,7 +15472,6 @@
             <a:spAutoFit/>
           </a:bodyPr>
           <a:lstStyle/>
-          <a:p/>
           <a:p>
             <a:pPr algn="l"/>
             <a:r>
@@ -15677,7 +15506,6 @@
             <a:spAutoFit/>
           </a:bodyPr>
           <a:lstStyle/>
-          <a:p/>
           <a:p>
             <a:pPr algn="l"/>
             <a:r>
@@ -15755,7 +15583,6 @@
             <a:spAutoFit/>
           </a:bodyPr>
           <a:lstStyle/>
-          <a:p/>
           <a:p>
             <a:pPr algn="l"/>
             <a:r>
@@ -15833,7 +15660,6 @@
             <a:spAutoFit/>
           </a:bodyPr>
           <a:lstStyle/>
-          <a:p/>
           <a:p>
             <a:pPr algn="l"/>
             <a:r>
@@ -15868,7 +15694,6 @@
             <a:spAutoFit/>
           </a:bodyPr>
           <a:lstStyle/>
-          <a:p/>
           <a:p>
             <a:pPr algn="l">
               <a:spcBef>
@@ -16130,7 +15955,6 @@
             <a:spAutoFit/>
           </a:bodyPr>
           <a:lstStyle/>
-          <a:p/>
           <a:p>
             <a:pPr algn="l"/>
             <a:r>
@@ -16165,7 +15989,6 @@
             <a:spAutoFit/>
           </a:bodyPr>
           <a:lstStyle/>
-          <a:p/>
           <a:p>
             <a:pPr algn="l">
               <a:spcBef>
@@ -16427,7 +16250,6 @@
             <a:spAutoFit/>
           </a:bodyPr>
           <a:lstStyle/>
-          <a:p/>
           <a:p>
             <a:pPr algn="ctr"/>
             <a:r>
@@ -16462,7 +16284,6 @@
             <a:spAutoFit/>
           </a:bodyPr>
           <a:lstStyle/>
-          <a:p/>
           <a:p>
             <a:pPr algn="r"/>
             <a:r>
@@ -16601,7 +16422,6 @@
             <a:spAutoFit/>
           </a:bodyPr>
           <a:lstStyle/>
-          <a:p/>
           <a:p>
             <a:pPr algn="l"/>
             <a:r>
@@ -16636,7 +16456,6 @@
             <a:spAutoFit/>
           </a:bodyPr>
           <a:lstStyle/>
-          <a:p/>
           <a:p>
             <a:pPr algn="l"/>
             <a:r>
@@ -16714,7 +16533,6 @@
             <a:spAutoFit/>
           </a:bodyPr>
           <a:lstStyle/>
-          <a:p/>
           <a:p>
             <a:pPr algn="l"/>
             <a:r>
@@ -16792,7 +16610,6 @@
             <a:spAutoFit/>
           </a:bodyPr>
           <a:lstStyle/>
-          <a:p/>
           <a:p>
             <a:pPr algn="l">
               <a:spcBef>
@@ -16934,7 +16751,6 @@
             <a:spAutoFit/>
           </a:bodyPr>
           <a:lstStyle/>
-          <a:p/>
           <a:p>
             <a:pPr algn="l"/>
             <a:r>
@@ -17012,7 +16828,6 @@
             <a:spAutoFit/>
           </a:bodyPr>
           <a:lstStyle/>
-          <a:p/>
           <a:p>
             <a:pPr algn="l">
               <a:spcBef>
@@ -17154,7 +16969,6 @@
             <a:spAutoFit/>
           </a:bodyPr>
           <a:lstStyle/>
-          <a:p/>
           <a:p>
             <a:pPr algn="l"/>
             <a:r>
@@ -17232,7 +17046,6 @@
             <a:spAutoFit/>
           </a:bodyPr>
           <a:lstStyle/>
-          <a:p/>
           <a:p>
             <a:pPr algn="l">
               <a:spcBef>
@@ -17374,7 +17187,6 @@
             <a:spAutoFit/>
           </a:bodyPr>
           <a:lstStyle/>
-          <a:p/>
           <a:p>
             <a:pPr algn="l"/>
             <a:r>
@@ -17452,7 +17264,6 @@
             <a:spAutoFit/>
           </a:bodyPr>
           <a:lstStyle/>
-          <a:p/>
           <a:p>
             <a:pPr algn="l">
               <a:spcBef>
@@ -17594,7 +17405,6 @@
             <a:spAutoFit/>
           </a:bodyPr>
           <a:lstStyle/>
-          <a:p/>
           <a:p>
             <a:pPr algn="l"/>
             <a:r>
@@ -17672,7 +17482,6 @@
             <a:spAutoFit/>
           </a:bodyPr>
           <a:lstStyle/>
-          <a:p/>
           <a:p>
             <a:pPr algn="l"/>
             <a:r>
@@ -17707,7 +17516,6 @@
             <a:spAutoFit/>
           </a:bodyPr>
           <a:lstStyle/>
-          <a:p/>
           <a:p>
             <a:pPr algn="l"/>
             <a:r>
@@ -17742,7 +17550,6 @@
             <a:spAutoFit/>
           </a:bodyPr>
           <a:lstStyle/>
-          <a:p/>
           <a:p>
             <a:pPr algn="l"/>
             <a:r>
@@ -17777,7 +17584,6 @@
             <a:spAutoFit/>
           </a:bodyPr>
           <a:lstStyle/>
-          <a:p/>
           <a:p>
             <a:pPr algn="l"/>
             <a:r>
@@ -17812,7 +17618,6 @@
             <a:spAutoFit/>
           </a:bodyPr>
           <a:lstStyle/>
-          <a:p/>
           <a:p>
             <a:pPr algn="l"/>
             <a:r>
@@ -17890,7 +17695,6 @@
             <a:spAutoFit/>
           </a:bodyPr>
           <a:lstStyle/>
-          <a:p/>
           <a:p>
             <a:pPr algn="l"/>
             <a:r>
@@ -17925,7 +17729,6 @@
             <a:spAutoFit/>
           </a:bodyPr>
           <a:lstStyle/>
-          <a:p/>
           <a:p>
             <a:pPr algn="l"/>
             <a:r>
@@ -17960,7 +17763,6 @@
             <a:spAutoFit/>
           </a:bodyPr>
           <a:lstStyle/>
-          <a:p/>
           <a:p>
             <a:pPr algn="l"/>
             <a:r>
@@ -17995,7 +17797,6 @@
             <a:spAutoFit/>
           </a:bodyPr>
           <a:lstStyle/>
-          <a:p/>
           <a:p>
             <a:pPr algn="l"/>
             <a:r>
@@ -18030,7 +17831,6 @@
             <a:spAutoFit/>
           </a:bodyPr>
           <a:lstStyle/>
-          <a:p/>
           <a:p>
             <a:pPr algn="l"/>
             <a:r>
@@ -18108,7 +17908,6 @@
             <a:spAutoFit/>
           </a:bodyPr>
           <a:lstStyle/>
-          <a:p/>
           <a:p>
             <a:pPr algn="l"/>
             <a:r>
@@ -18143,7 +17942,6 @@
             <a:spAutoFit/>
           </a:bodyPr>
           <a:lstStyle/>
-          <a:p/>
           <a:p>
             <a:pPr algn="l"/>
             <a:r>
@@ -18178,7 +17976,6 @@
             <a:spAutoFit/>
           </a:bodyPr>
           <a:lstStyle/>
-          <a:p/>
           <a:p>
             <a:pPr algn="l"/>
             <a:r>
@@ -18213,7 +18010,6 @@
             <a:spAutoFit/>
           </a:bodyPr>
           <a:lstStyle/>
-          <a:p/>
           <a:p>
             <a:pPr algn="l"/>
             <a:r>
@@ -18248,7 +18044,6 @@
             <a:spAutoFit/>
           </a:bodyPr>
           <a:lstStyle/>
-          <a:p/>
           <a:p>
             <a:pPr algn="l"/>
             <a:r>
@@ -18326,7 +18121,6 @@
             <a:spAutoFit/>
           </a:bodyPr>
           <a:lstStyle/>
-          <a:p/>
           <a:p>
             <a:pPr algn="l"/>
             <a:r>
@@ -18361,7 +18155,6 @@
             <a:spAutoFit/>
           </a:bodyPr>
           <a:lstStyle/>
-          <a:p/>
           <a:p>
             <a:pPr algn="l"/>
             <a:r>
@@ -18396,7 +18189,6 @@
             <a:spAutoFit/>
           </a:bodyPr>
           <a:lstStyle/>
-          <a:p/>
           <a:p>
             <a:pPr algn="l"/>
             <a:r>
@@ -18431,7 +18223,6 @@
             <a:spAutoFit/>
           </a:bodyPr>
           <a:lstStyle/>
-          <a:p/>
           <a:p>
             <a:pPr algn="l"/>
             <a:r>
@@ -18466,7 +18257,6 @@
             <a:spAutoFit/>
           </a:bodyPr>
           <a:lstStyle/>
-          <a:p/>
           <a:p>
             <a:pPr algn="l"/>
             <a:r>
@@ -18544,7 +18334,6 @@
             <a:spAutoFit/>
           </a:bodyPr>
           <a:lstStyle/>
-          <a:p/>
           <a:p>
             <a:pPr algn="l"/>
             <a:r>
@@ -18579,7 +18368,6 @@
             <a:spAutoFit/>
           </a:bodyPr>
           <a:lstStyle/>
-          <a:p/>
           <a:p>
             <a:pPr algn="l"/>
             <a:r>
@@ -18614,7 +18402,6 @@
             <a:spAutoFit/>
           </a:bodyPr>
           <a:lstStyle/>
-          <a:p/>
           <a:p>
             <a:pPr algn="l"/>
             <a:r>
@@ -18649,7 +18436,6 @@
             <a:spAutoFit/>
           </a:bodyPr>
           <a:lstStyle/>
-          <a:p/>
           <a:p>
             <a:pPr algn="l"/>
             <a:r>
@@ -18684,7 +18470,6 @@
             <a:spAutoFit/>
           </a:bodyPr>
           <a:lstStyle/>
-          <a:p/>
           <a:p>
             <a:pPr algn="l"/>
             <a:r>
@@ -18762,7 +18547,6 @@
             <a:spAutoFit/>
           </a:bodyPr>
           <a:lstStyle/>
-          <a:p/>
           <a:p>
             <a:pPr algn="l"/>
             <a:r>
@@ -18797,7 +18581,6 @@
             <a:spAutoFit/>
           </a:bodyPr>
           <a:lstStyle/>
-          <a:p/>
           <a:p>
             <a:pPr algn="l">
               <a:spcBef>
@@ -18836,7 +18619,6 @@
             <a:spAutoFit/>
           </a:bodyPr>
           <a:lstStyle/>
-          <a:p/>
           <a:p>
             <a:pPr algn="r"/>
             <a:r>

</xml_diff>